<commit_message>
add save test in api, mini fixes
</commit_message>
<xml_diff>
--- a/doc/tastyai_presentation.pptx
+++ b/doc/tastyai_presentation.pptx
@@ -5,20 +5,18 @@
     <p:sldMasterId id="2147483648" r:id="rId4"/>
   </p:sldMasterIdLst>
   <p:notesMasterIdLst>
-    <p:notesMasterId r:id="rId13"/>
+    <p:notesMasterId r:id="rId11"/>
   </p:notesMasterIdLst>
   <p:handoutMasterIdLst>
-    <p:handoutMasterId r:id="rId14"/>
+    <p:handoutMasterId r:id="rId12"/>
   </p:handoutMasterIdLst>
   <p:sldIdLst>
     <p:sldId id="256" r:id="rId5"/>
-    <p:sldId id="269" r:id="rId6"/>
-    <p:sldId id="270" r:id="rId7"/>
-    <p:sldId id="276" r:id="rId8"/>
-    <p:sldId id="277" r:id="rId9"/>
-    <p:sldId id="273" r:id="rId10"/>
-    <p:sldId id="272" r:id="rId11"/>
-    <p:sldId id="275" r:id="rId12"/>
+    <p:sldId id="270" r:id="rId6"/>
+    <p:sldId id="276" r:id="rId7"/>
+    <p:sldId id="277" r:id="rId8"/>
+    <p:sldId id="273" r:id="rId9"/>
+    <p:sldId id="275" r:id="rId10"/>
   </p:sldIdLst>
   <p:sldSz cx="12192000" cy="6858000"/>
   <p:notesSz cx="6858000" cy="9144000"/>
@@ -240,7 +238,7 @@
             <a:pPr rtl="0"/>
             <a:fld id="{F44019DA-0277-4D42-8F8F-25376A1D1F89}" type="datetime1">
               <a:rPr lang="ru-RU" smtClean="0"/>
-              <a:t>26.04.2025</a:t>
+              <a:t>07.05.2026</a:t>
             </a:fld>
             <a:endParaRPr lang="ru-RU" dirty="0"/>
           </a:p>
@@ -421,7 +419,7 @@
             <a:fld id="{678DE31B-A03F-4E9D-89BE-E86BF93D05F0}" type="datetime1">
               <a:rPr lang="ru-RU" smtClean="0"/>
               <a:pPr/>
-              <a:t>26.04.2025</a:t>
+              <a:t>07.05.2026</a:t>
             </a:fld>
             <a:endParaRPr lang="ru-RU" dirty="0"/>
           </a:p>
@@ -844,93 +842,7 @@
             <a:pPr rtl="0"/>
             <a:fld id="{79230CFA-805A-4FD3-B3A0-DAAA5993DA17}" type="slidenum">
               <a:rPr lang="ru-RU" smtClean="0"/>
-              <a:t>2</a:t>
-            </a:fld>
-            <a:endParaRPr lang="ru-RU" dirty="0"/>
-          </a:p>
-        </p:txBody>
-      </p:sp>
-    </p:spTree>
-    <p:extLst>
-      <p:ext uri="{BB962C8B-B14F-4D97-AF65-F5344CB8AC3E}">
-        <p14:creationId xmlns:p14="http://schemas.microsoft.com/office/powerpoint/2010/main" val="2964907776"/>
-      </p:ext>
-    </p:extLst>
-  </p:cSld>
-  <p:clrMapOvr>
-    <a:masterClrMapping/>
-  </p:clrMapOvr>
-</p:notes>
-</file>
-
-<file path=ppt/notesSlides/notesSlide3.xml><?xml version="1.0" encoding="utf-8"?>
-<p:notes xmlns:a="http://schemas.openxmlformats.org/drawingml/2006/main" xmlns:r="http://schemas.openxmlformats.org/officeDocument/2006/relationships" xmlns:p="http://schemas.openxmlformats.org/presentationml/2006/main">
-  <p:cSld>
-    <p:spTree>
-      <p:nvGrpSpPr>
-        <p:cNvPr id="1" name=""/>
-        <p:cNvGrpSpPr/>
-        <p:nvPr/>
-      </p:nvGrpSpPr>
-      <p:grpSpPr>
-        <a:xfrm>
-          <a:off x="0" y="0"/>
-          <a:ext cx="0" cy="0"/>
-          <a:chOff x="0" y="0"/>
-          <a:chExt cx="0" cy="0"/>
-        </a:xfrm>
-      </p:grpSpPr>
-      <p:sp>
-        <p:nvSpPr>
-          <p:cNvPr id="2" name="Образ слайда 1"/>
-          <p:cNvSpPr>
-            <a:spLocks noGrp="1" noRot="1" noChangeAspect="1"/>
-          </p:cNvSpPr>
-          <p:nvPr>
-            <p:ph type="sldImg"/>
-          </p:nvPr>
-        </p:nvSpPr>
-        <p:spPr/>
-      </p:sp>
-      <p:sp>
-        <p:nvSpPr>
-          <p:cNvPr id="3" name="Заметки 2"/>
-          <p:cNvSpPr>
-            <a:spLocks noGrp="1"/>
-          </p:cNvSpPr>
-          <p:nvPr>
-            <p:ph type="body" idx="1"/>
-          </p:nvPr>
-        </p:nvSpPr>
-        <p:spPr/>
-        <p:txBody>
-          <a:bodyPr rtlCol="0"/>
-          <a:lstStyle/>
-          <a:p>
-            <a:pPr rtl="0"/>
-            <a:endParaRPr lang="ru-RU" dirty="0"/>
-          </a:p>
-        </p:txBody>
-      </p:sp>
-      <p:sp>
-        <p:nvSpPr>
-          <p:cNvPr id="4" name="Номер слайда 3"/>
-          <p:cNvSpPr>
-            <a:spLocks noGrp="1"/>
-          </p:cNvSpPr>
-          <p:nvPr>
-            <p:ph type="sldNum" sz="quarter" idx="10"/>
-          </p:nvPr>
-        </p:nvSpPr>
-        <p:spPr/>
-        <p:txBody>
-          <a:bodyPr rtlCol="0"/>
-          <a:lstStyle/>
-          <a:p>
-            <a:pPr rtl="0"/>
-            <a:fld id="{79230CFA-805A-4FD3-B3A0-DAAA5993DA17}" type="slidenum">
-              <a:rPr lang="ru-RU" smtClean="0"/>
-              <a:t>8</a:t>
+              <a:t>6</a:t>
             </a:fld>
             <a:endParaRPr lang="ru-RU" dirty="0"/>
           </a:p>
@@ -12962,11 +12874,23 @@
           <a:bodyPr rtlCol="0"/>
           <a:lstStyle/>
           <a:p>
-            <a:pPr rtl="0"/>
             <a:r>
               <a:rPr lang="ru-RU" dirty="0"/>
-              <a:t>Воплощение кейса: «Веб-сервис для создания и проведения опросов с визуализацией результатов»</a:t>
-            </a:r>
+              <a:t>«Проект </a:t>
+            </a:r>
+            <a:r>
+              <a:rPr lang="en-US" dirty="0" err="1"/>
+              <a:t>WebServer</a:t>
+            </a:r>
+            <a:r>
+              <a:rPr lang="en-US" dirty="0"/>
+              <a:t> + API</a:t>
+            </a:r>
+            <a:r>
+              <a:rPr lang="ru-RU" dirty="0"/>
+              <a:t>» для курса Промышленное программирование в Яндекс Лицее</a:t>
+            </a:r>
+            <a:endParaRPr lang="en-US" dirty="0"/>
           </a:p>
         </p:txBody>
       </p:sp>
@@ -13015,7 +12939,7 @@
         <p:spPr>
           <a:xfrm>
             <a:off x="6375214" y="5074755"/>
-            <a:ext cx="4697506" cy="369332"/>
+            <a:ext cx="4697506" cy="646331"/>
           </a:xfrm>
           <a:prstGeom prst="rect">
             <a:avLst/>
@@ -13030,7 +12954,13 @@
           <a:p>
             <a:r>
               <a:rPr lang="ru-RU" dirty="0"/>
-              <a:t>г. Нижневартовск, МБОУ «Лицей №2» 8 класс</a:t>
+              <a:t>Минибаев Артём и Тимофей Савицкий</a:t>
+            </a:r>
+          </a:p>
+          <a:p>
+            <a:r>
+              <a:rPr lang="ru-RU" dirty="0"/>
+              <a:t>г. Нижневартовск, МБОУ «Лицей №2» 9 класс</a:t>
             </a:r>
           </a:p>
         </p:txBody>
@@ -13067,10 +12997,10 @@
       </p:grpSpPr>
       <p:sp>
         <p:nvSpPr>
-          <p:cNvPr id="14" name="Заголовок 13">
-            <a:extLst>
-              <a:ext uri="{FF2B5EF4-FFF2-40B4-BE49-F238E27FC236}">
-                <a16:creationId xmlns:a16="http://schemas.microsoft.com/office/drawing/2014/main" id="{E3E5EE03-FBF6-46F5-8085-716AC6CE1C8C}"/>
+          <p:cNvPr id="2" name="Заголовок 1">
+            <a:extLst>
+              <a:ext uri="{FF2B5EF4-FFF2-40B4-BE49-F238E27FC236}">
+                <a16:creationId xmlns:a16="http://schemas.microsoft.com/office/drawing/2014/main" id="{9DED2AD5-5924-4E02-824F-0408286B998D}"/>
               </a:ext>
             </a:extLst>
           </p:cNvPr>
@@ -13083,125 +13013,35 @@
         </p:nvSpPr>
         <p:spPr>
           <a:xfrm>
-            <a:off x="7793636" y="739775"/>
-            <a:ext cx="2961002" cy="702573"/>
+            <a:off x="1198267" y="2195082"/>
+            <a:ext cx="3995918" cy="1789855"/>
           </a:xfrm>
         </p:spPr>
         <p:txBody>
-          <a:bodyPr rtlCol="0">
-            <a:normAutofit/>
-          </a:bodyPr>
+          <a:bodyPr/>
           <a:lstStyle/>
           <a:p>
-            <a:pPr rtl="0"/>
+            <a:r>
+              <a:rPr lang="en-US" dirty="0" err="1"/>
+              <a:t>TastyAI</a:t>
+            </a:r>
+            <a:r>
+              <a:rPr lang="en-US" dirty="0"/>
+              <a:t> – </a:t>
+            </a:r>
             <a:r>
               <a:rPr lang="ru-RU" dirty="0"/>
-              <a:t>Наш состав</a:t>
-            </a:r>
-            <a:endParaRPr lang="ru-RU" b="0" dirty="0"/>
+              <a:t>онлайн тесты с ИИ</a:t>
+            </a:r>
           </a:p>
         </p:txBody>
       </p:sp>
       <p:sp>
         <p:nvSpPr>
-          <p:cNvPr id="19" name="Текст 18">
-            <a:extLst>
-              <a:ext uri="{FF2B5EF4-FFF2-40B4-BE49-F238E27FC236}">
-                <a16:creationId xmlns:a16="http://schemas.microsoft.com/office/drawing/2014/main" id="{DFE11F38-F66B-4F95-8224-6CCA69D57617}"/>
-              </a:ext>
-            </a:extLst>
-          </p:cNvPr>
-          <p:cNvSpPr>
-            <a:spLocks noGrp="1"/>
-          </p:cNvSpPr>
-          <p:nvPr>
-            <p:ph type="body" sz="quarter" idx="16"/>
-          </p:nvPr>
-        </p:nvSpPr>
-        <p:spPr>
-          <a:xfrm>
-            <a:off x="519119" y="1158740"/>
-            <a:ext cx="6985658" cy="998715"/>
-          </a:xfrm>
-        </p:spPr>
-        <p:txBody>
-          <a:bodyPr rtlCol="0"/>
-          <a:lstStyle/>
-          <a:p>
-            <a:r>
-              <a:rPr lang="ru-RU" sz="2200" dirty="0"/>
-              <a:t>Мы «Отряд </a:t>
-            </a:r>
-            <a:r>
-              <a:rPr lang="ru-RU" sz="2200" dirty="0" err="1"/>
-              <a:t>кодоубийц</a:t>
-            </a:r>
-            <a:r>
-              <a:rPr lang="ru-RU" sz="2200" dirty="0"/>
-              <a:t>»</a:t>
-            </a:r>
-            <a:br>
-              <a:rPr lang="ru-RU" sz="2200" dirty="0"/>
-            </a:br>
-            <a:r>
-              <a:rPr lang="ru-RU" sz="2200" dirty="0">
-                <a:solidFill>
-                  <a:schemeClr val="tx1">
-                    <a:lumMod val="75000"/>
-                  </a:schemeClr>
-                </a:solidFill>
-              </a:rPr>
-              <a:t>Занимаемся программированием на </a:t>
-            </a:r>
-            <a:r>
-              <a:rPr lang="en-US" sz="2200" dirty="0">
-                <a:solidFill>
-                  <a:schemeClr val="tx1">
-                    <a:lumMod val="75000"/>
-                  </a:schemeClr>
-                </a:solidFill>
-              </a:rPr>
-              <a:t>Python </a:t>
-            </a:r>
-            <a:r>
-              <a:rPr lang="ru-RU" sz="2200" dirty="0">
-                <a:solidFill>
-                  <a:schemeClr val="tx1">
-                    <a:lumMod val="75000"/>
-                  </a:schemeClr>
-                </a:solidFill>
-              </a:rPr>
-              <a:t>уже 3 года.</a:t>
-            </a:r>
-            <a:r>
-              <a:rPr lang="en-US" sz="2200" dirty="0">
-                <a:solidFill>
-                  <a:schemeClr val="tx1">
-                    <a:lumMod val="75000"/>
-                  </a:schemeClr>
-                </a:solidFill>
-              </a:rPr>
-              <a:t> </a:t>
-            </a:r>
-            <a:r>
-              <a:rPr lang="ru-RU" sz="2200" dirty="0">
-                <a:solidFill>
-                  <a:schemeClr val="tx1">
-                    <a:lumMod val="75000"/>
-                  </a:schemeClr>
-                </a:solidFill>
-              </a:rPr>
-              <a:t>Созданием сайтов 1 год.</a:t>
-            </a:r>
-          </a:p>
-        </p:txBody>
-      </p:sp>
-      <p:sp>
-        <p:nvSpPr>
-          <p:cNvPr id="15" name="Текст 14">
-            <a:extLst>
-              <a:ext uri="{FF2B5EF4-FFF2-40B4-BE49-F238E27FC236}">
-                <a16:creationId xmlns:a16="http://schemas.microsoft.com/office/drawing/2014/main" id="{24E18385-8BEA-4522-ABAA-5AB38F0D4FC2}"/>
+          <p:cNvPr id="3" name="Текст 2">
+            <a:extLst>
+              <a:ext uri="{FF2B5EF4-FFF2-40B4-BE49-F238E27FC236}">
+                <a16:creationId xmlns:a16="http://schemas.microsoft.com/office/drawing/2014/main" id="{25411CA9-89E5-4FD9-95E7-36230AD1331C}"/>
               </a:ext>
             </a:extLst>
           </p:cNvPr>
@@ -13214,304 +13054,59 @@
         </p:nvSpPr>
         <p:spPr>
           <a:xfrm>
-            <a:off x="520698" y="2395582"/>
-            <a:ext cx="5475290" cy="490494"/>
+            <a:off x="461782" y="3984937"/>
+            <a:ext cx="5468887" cy="1940734"/>
           </a:xfrm>
         </p:spPr>
         <p:txBody>
-          <a:bodyPr rtlCol="0">
+          <a:bodyPr>
             <a:noAutofit/>
           </a:bodyPr>
           <a:lstStyle/>
           <a:p>
-            <a:pPr rtl="0"/>
-            <a:r>
-              <a:rPr lang="ru-RU" sz="3200" dirty="0" err="1"/>
-              <a:t>Минибаев</a:t>
-            </a:r>
-            <a:r>
-              <a:rPr lang="ru-RU" sz="3200" dirty="0"/>
-              <a:t> Артём</a:t>
+            <a:r>
+              <a:rPr lang="ru-RU" sz="2700" dirty="0"/>
+              <a:t>- это абсолютно бесплатный сайт с тестами где используется искусственный интеллект для ваших разных задач в области тестов.</a:t>
             </a:r>
           </a:p>
         </p:txBody>
       </p:sp>
+      <p:pic>
+        <p:nvPicPr>
+          <p:cNvPr id="9" name="Рисунок 8">
+            <a:extLst>
+              <a:ext uri="{FF2B5EF4-FFF2-40B4-BE49-F238E27FC236}">
+                <a16:creationId xmlns:a16="http://schemas.microsoft.com/office/drawing/2014/main" id="{D6B7648D-348E-423A-A9F8-14BE77953C78}"/>
+              </a:ext>
+            </a:extLst>
+          </p:cNvPr>
+          <p:cNvPicPr>
+            <a:picLocks noChangeAspect="1"/>
+          </p:cNvPicPr>
+          <p:nvPr/>
+        </p:nvPicPr>
+        <p:blipFill>
+          <a:blip r:embed="rId2"/>
+          <a:stretch>
+            <a:fillRect/>
+          </a:stretch>
+        </p:blipFill>
+        <p:spPr>
+          <a:xfrm>
+            <a:off x="122974" y="660345"/>
+            <a:ext cx="5734971" cy="1597080"/>
+          </a:xfrm>
+          <a:prstGeom prst="rect">
+            <a:avLst/>
+          </a:prstGeom>
+        </p:spPr>
+      </p:pic>
       <p:sp>
         <p:nvSpPr>
-          <p:cNvPr id="16" name="Объект 15">
-            <a:extLst>
-              <a:ext uri="{FF2B5EF4-FFF2-40B4-BE49-F238E27FC236}">
-                <a16:creationId xmlns:a16="http://schemas.microsoft.com/office/drawing/2014/main" id="{1DCFA8A2-3FB8-48CA-933D-0800A9D2A2A2}"/>
-              </a:ext>
-            </a:extLst>
-          </p:cNvPr>
-          <p:cNvSpPr>
-            <a:spLocks noGrp="1"/>
-          </p:cNvSpPr>
-          <p:nvPr>
-            <p:ph sz="half" idx="13"/>
-          </p:nvPr>
-        </p:nvSpPr>
-        <p:spPr/>
-        <p:txBody>
-          <a:bodyPr rtlCol="0"/>
-          <a:lstStyle/>
-          <a:p>
-            <a:pPr rtl="0">
-              <a:buClr>
-                <a:schemeClr val="accent2"/>
-              </a:buClr>
-            </a:pPr>
-            <a:r>
-              <a:rPr lang="ru-RU" sz="2800" dirty="0"/>
-              <a:t>Командир. </a:t>
-            </a:r>
-            <a:r>
-              <a:rPr lang="en-US" sz="2800" dirty="0"/>
-              <a:t>Backend</a:t>
-            </a:r>
-            <a:r>
-              <a:rPr lang="ru-RU" sz="2800" dirty="0"/>
-              <a:t>/</a:t>
-            </a:r>
-            <a:r>
-              <a:rPr lang="en-US" sz="2800" dirty="0"/>
-              <a:t>Frontend</a:t>
-            </a:r>
-            <a:r>
-              <a:rPr lang="ru-RU" sz="2800" dirty="0"/>
-              <a:t> разработчик.</a:t>
-            </a:r>
-          </a:p>
-          <a:p>
-            <a:pPr lvl="1" rtl="0">
-              <a:buClr>
-                <a:schemeClr val="accent2"/>
-              </a:buClr>
-            </a:pPr>
-            <a:r>
-              <a:rPr lang="ru-RU" sz="2400" dirty="0"/>
-              <a:t>Делал всю работу которая относится к программированию.</a:t>
-            </a:r>
-          </a:p>
-          <a:p>
-            <a:pPr lvl="1" rtl="0">
-              <a:buClr>
-                <a:schemeClr val="accent2"/>
-              </a:buClr>
-            </a:pPr>
-            <a:r>
-              <a:rPr lang="ru-RU" sz="2400" dirty="0"/>
-              <a:t>Админ сервера сайта.</a:t>
-            </a:r>
-            <a:endParaRPr lang="en-US" sz="2400" dirty="0"/>
-          </a:p>
-          <a:p>
-            <a:pPr marL="457200" lvl="1" indent="0" rtl="0">
-              <a:buClr>
-                <a:schemeClr val="accent2"/>
-              </a:buClr>
-              <a:buNone/>
-            </a:pPr>
-            <a:r>
-              <a:rPr lang="ru-RU" sz="2400" dirty="0"/>
-              <a:t>Связь:</a:t>
-            </a:r>
-            <a:br>
-              <a:rPr lang="ru-RU" sz="2400" dirty="0"/>
-            </a:br>
-            <a:r>
-              <a:rPr lang="ru-RU" sz="2400" dirty="0"/>
-              <a:t>	</a:t>
-            </a:r>
-            <a:r>
-              <a:rPr lang="en-US" sz="2400" dirty="0"/>
-              <a:t>Telegram: @u53rnm3</a:t>
-            </a:r>
-          </a:p>
-          <a:p>
-            <a:pPr marL="457200" lvl="1" indent="0" rtl="0">
-              <a:buClr>
-                <a:schemeClr val="accent2"/>
-              </a:buClr>
-              <a:buNone/>
-            </a:pPr>
-            <a:r>
-              <a:rPr lang="ru-RU" sz="2400" dirty="0"/>
-              <a:t>	</a:t>
-            </a:r>
-            <a:r>
-              <a:rPr lang="en-US" sz="2400" dirty="0"/>
-              <a:t>VK: https://vk.com/mini_artem</a:t>
-            </a:r>
-            <a:endParaRPr lang="ru-RU" sz="2400" dirty="0"/>
-          </a:p>
-        </p:txBody>
-      </p:sp>
-      <p:sp>
-        <p:nvSpPr>
-          <p:cNvPr id="17" name="Текст 16">
-            <a:extLst>
-              <a:ext uri="{FF2B5EF4-FFF2-40B4-BE49-F238E27FC236}">
-                <a16:creationId xmlns:a16="http://schemas.microsoft.com/office/drawing/2014/main" id="{640A3223-3DA3-4CF2-82B6-1447667547BD}"/>
-              </a:ext>
-            </a:extLst>
-          </p:cNvPr>
-          <p:cNvSpPr>
-            <a:spLocks noGrp="1"/>
-          </p:cNvSpPr>
-          <p:nvPr>
-            <p:ph type="body" sz="quarter" idx="14"/>
-          </p:nvPr>
-        </p:nvSpPr>
-        <p:spPr>
-          <a:xfrm>
-            <a:off x="6186713" y="2395580"/>
-            <a:ext cx="5475600" cy="490495"/>
-          </a:xfrm>
-        </p:spPr>
-        <p:txBody>
-          <a:bodyPr rtlCol="0">
-            <a:noAutofit/>
-          </a:bodyPr>
-          <a:lstStyle/>
-          <a:p>
-            <a:pPr rtl="0"/>
-            <a:r>
-              <a:rPr lang="ru-RU" sz="3200" dirty="0"/>
-              <a:t>Савицкий Тимофей</a:t>
-            </a:r>
-          </a:p>
-        </p:txBody>
-      </p:sp>
-      <p:sp>
-        <p:nvSpPr>
-          <p:cNvPr id="18" name="Объект 17">
-            <a:extLst>
-              <a:ext uri="{FF2B5EF4-FFF2-40B4-BE49-F238E27FC236}">
-                <a16:creationId xmlns:a16="http://schemas.microsoft.com/office/drawing/2014/main" id="{C955AFB3-173C-4848-B3E9-1375591B297E}"/>
-              </a:ext>
-            </a:extLst>
-          </p:cNvPr>
-          <p:cNvSpPr>
-            <a:spLocks noGrp="1"/>
-          </p:cNvSpPr>
-          <p:nvPr>
-            <p:ph sz="quarter" idx="15"/>
-          </p:nvPr>
-        </p:nvSpPr>
-        <p:spPr/>
-        <p:txBody>
-          <a:bodyPr rtlCol="0"/>
-          <a:lstStyle/>
-          <a:p>
-            <a:pPr rtl="0">
-              <a:buClr>
-                <a:schemeClr val="accent2"/>
-              </a:buClr>
-            </a:pPr>
-            <a:r>
-              <a:rPr lang="ru-RU" sz="2800" dirty="0"/>
-              <a:t>Участник. Дизайнер.</a:t>
-            </a:r>
-          </a:p>
-          <a:p>
-            <a:pPr lvl="1" rtl="0">
-              <a:buClr>
-                <a:schemeClr val="accent2"/>
-              </a:buClr>
-            </a:pPr>
-            <a:r>
-              <a:rPr lang="ru-RU" sz="2400" dirty="0"/>
-              <a:t>Делал всё что относится к строению и виду сайта.</a:t>
-            </a:r>
-          </a:p>
-          <a:p>
-            <a:pPr lvl="1" rtl="0">
-              <a:buClr>
-                <a:schemeClr val="accent2"/>
-              </a:buClr>
-            </a:pPr>
-            <a:r>
-              <a:rPr lang="ru-RU" sz="2400" dirty="0"/>
-              <a:t>Придумал дизайн сайта.</a:t>
-            </a:r>
-            <a:endParaRPr lang="en-US" sz="2400" dirty="0"/>
-          </a:p>
-          <a:p>
-            <a:pPr marL="457200" lvl="1" indent="0" rtl="0">
-              <a:buClr>
-                <a:schemeClr val="accent2"/>
-              </a:buClr>
-              <a:buNone/>
-            </a:pPr>
-            <a:r>
-              <a:rPr lang="ru-RU" sz="2400" dirty="0"/>
-              <a:t>Связь:</a:t>
-            </a:r>
-            <a:br>
-              <a:rPr lang="ru-RU" sz="2400" dirty="0"/>
-            </a:br>
-            <a:r>
-              <a:rPr lang="ru-RU" sz="2400" dirty="0"/>
-              <a:t>	</a:t>
-            </a:r>
-            <a:r>
-              <a:rPr lang="en-US" sz="2400" dirty="0"/>
-              <a:t>Telegram: @WhataHeeeeeell</a:t>
-            </a:r>
-            <a:endParaRPr lang="ru-RU" sz="2400" dirty="0"/>
-          </a:p>
-        </p:txBody>
-      </p:sp>
-      <p:sp>
-        <p:nvSpPr>
-          <p:cNvPr id="21" name="Номер слайда 5">
-            <a:extLst>
-              <a:ext uri="{FF2B5EF4-FFF2-40B4-BE49-F238E27FC236}">
-                <a16:creationId xmlns:a16="http://schemas.microsoft.com/office/drawing/2014/main" id="{C7C65DDB-24F2-44CF-AE02-F3A6C8B1858B}"/>
-              </a:ext>
-            </a:extLst>
-          </p:cNvPr>
-          <p:cNvSpPr>
-            <a:spLocks noGrp="1"/>
-          </p:cNvSpPr>
-          <p:nvPr>
-            <p:ph type="sldNum" sz="quarter" idx="18"/>
-          </p:nvPr>
-        </p:nvSpPr>
-        <p:spPr/>
-        <p:txBody>
-          <a:bodyPr rtlCol="0"/>
-          <a:lstStyle>
-            <a:lvl1pPr algn="r">
-              <a:defRPr sz="1200">
-                <a:solidFill>
-                  <a:schemeClr val="tx1">
-                    <a:lumMod val="50000"/>
-                    <a:lumOff val="50000"/>
-                  </a:schemeClr>
-                </a:solidFill>
-              </a:defRPr>
-            </a:lvl1pPr>
-          </a:lstStyle>
-          <a:p>
-            <a:pPr rtl="0"/>
-            <a:fld id="{8699F50C-BE38-4BD0-BA84-9B090E1F2B9B}" type="slidenum">
-              <a:rPr lang="ru-RU" smtClean="0"/>
-              <a:pPr rtl="0"/>
-              <a:t>2</a:t>
-            </a:fld>
-            <a:endParaRPr lang="ru-RU" dirty="0"/>
-          </a:p>
-        </p:txBody>
-      </p:sp>
-      <p:sp>
-        <p:nvSpPr>
-          <p:cNvPr id="10" name="Нижний колонтитул 1">
-            <a:extLst>
-              <a:ext uri="{FF2B5EF4-FFF2-40B4-BE49-F238E27FC236}">
-                <a16:creationId xmlns:a16="http://schemas.microsoft.com/office/drawing/2014/main" id="{A243F6A9-0680-41DB-9C29-B5432EE31349}"/>
+          <p:cNvPr id="13" name="Нижний колонтитул 1">
+            <a:extLst>
+              <a:ext uri="{FF2B5EF4-FFF2-40B4-BE49-F238E27FC236}">
+                <a16:creationId xmlns:a16="http://schemas.microsoft.com/office/drawing/2014/main" id="{46CE1A0C-FB01-4D4F-A11A-1B495307CAC2}"/>
               </a:ext>
             </a:extLst>
           </p:cNvPr>
@@ -13635,10 +13230,276 @@
           </a:p>
         </p:txBody>
       </p:sp>
+      <p:sp>
+        <p:nvSpPr>
+          <p:cNvPr id="7" name="Объект 4">
+            <a:extLst>
+              <a:ext uri="{FF2B5EF4-FFF2-40B4-BE49-F238E27FC236}">
+                <a16:creationId xmlns:a16="http://schemas.microsoft.com/office/drawing/2014/main" id="{B7AC610B-A440-4F80-B128-587794215A34}"/>
+              </a:ext>
+            </a:extLst>
+          </p:cNvPr>
+          <p:cNvSpPr txBox="1">
+            <a:spLocks/>
+          </p:cNvSpPr>
+          <p:nvPr/>
+        </p:nvSpPr>
+        <p:spPr>
+          <a:xfrm>
+            <a:off x="6078071" y="3090010"/>
+            <a:ext cx="5968786" cy="2835662"/>
+          </a:xfrm>
+          <a:prstGeom prst="rect">
+            <a:avLst/>
+          </a:prstGeom>
+        </p:spPr>
+        <p:txBody>
+          <a:bodyPr rtlCol="0">
+            <a:normAutofit/>
+          </a:bodyPr>
+          <a:lstStyle>
+            <a:lvl1pPr marL="0" indent="0" algn="l" defTabSz="914400" rtl="0" eaLnBrk="1" latinLnBrk="0" hangingPunct="1">
+              <a:lnSpc>
+                <a:spcPct val="90000"/>
+              </a:lnSpc>
+              <a:spcBef>
+                <a:spcPts val="1000"/>
+              </a:spcBef>
+              <a:buClr>
+                <a:srgbClr val="2E7A40"/>
+              </a:buClr>
+              <a:buFont typeface="Arial" panose="020B0604020202020204" pitchFamily="34" charset="0"/>
+              <a:buNone/>
+              <a:defRPr lang="en-US" sz="2000" b="0" i="0" kern="1200" spc="300">
+                <a:solidFill>
+                  <a:schemeClr val="accent6"/>
+                </a:solidFill>
+                <a:latin typeface="+mn-lt"/>
+                <a:ea typeface="+mn-ea"/>
+                <a:cs typeface="Calibri" panose="020F0502020204030204" pitchFamily="34" charset="0"/>
+              </a:defRPr>
+            </a:lvl1pPr>
+            <a:lvl2pPr marL="457200" indent="0" algn="l" defTabSz="914400" rtl="0" eaLnBrk="1" latinLnBrk="0" hangingPunct="1">
+              <a:lnSpc>
+                <a:spcPct val="90000"/>
+              </a:lnSpc>
+              <a:spcBef>
+                <a:spcPts val="500"/>
+              </a:spcBef>
+              <a:buClr>
+                <a:srgbClr val="2E7A40"/>
+              </a:buClr>
+              <a:buFont typeface="Arial" panose="020B0604020202020204" pitchFamily="34" charset="0"/>
+              <a:buNone/>
+              <a:defRPr lang="en-US" sz="2000" kern="1200">
+                <a:solidFill>
+                  <a:schemeClr val="tx1">
+                    <a:tint val="75000"/>
+                  </a:schemeClr>
+                </a:solidFill>
+                <a:latin typeface="+mn-lt"/>
+                <a:ea typeface="+mn-ea"/>
+                <a:cs typeface="+mn-cs"/>
+              </a:defRPr>
+            </a:lvl2pPr>
+            <a:lvl3pPr marL="914400" indent="0" algn="l" defTabSz="914400" rtl="0" eaLnBrk="1" latinLnBrk="0" hangingPunct="1">
+              <a:lnSpc>
+                <a:spcPct val="90000"/>
+              </a:lnSpc>
+              <a:spcBef>
+                <a:spcPts val="500"/>
+              </a:spcBef>
+              <a:buClr>
+                <a:srgbClr val="2E7A40"/>
+              </a:buClr>
+              <a:buFont typeface="Arial" panose="020B0604020202020204" pitchFamily="34" charset="0"/>
+              <a:buNone/>
+              <a:defRPr lang="en-US" sz="1800" kern="1200">
+                <a:solidFill>
+                  <a:schemeClr val="tx1">
+                    <a:tint val="75000"/>
+                  </a:schemeClr>
+                </a:solidFill>
+                <a:latin typeface="+mn-lt"/>
+                <a:ea typeface="+mn-ea"/>
+                <a:cs typeface="+mn-cs"/>
+              </a:defRPr>
+            </a:lvl3pPr>
+            <a:lvl4pPr marL="1371600" indent="0" algn="l" defTabSz="914400" rtl="0" eaLnBrk="1" latinLnBrk="0" hangingPunct="1">
+              <a:lnSpc>
+                <a:spcPct val="90000"/>
+              </a:lnSpc>
+              <a:spcBef>
+                <a:spcPts val="500"/>
+              </a:spcBef>
+              <a:buClr>
+                <a:srgbClr val="2E7A40"/>
+              </a:buClr>
+              <a:buFont typeface="Arial" panose="020B0604020202020204" pitchFamily="34" charset="0"/>
+              <a:buNone/>
+              <a:defRPr lang="en-US" sz="1600" kern="1200">
+                <a:solidFill>
+                  <a:schemeClr val="tx1">
+                    <a:tint val="75000"/>
+                  </a:schemeClr>
+                </a:solidFill>
+                <a:latin typeface="+mn-lt"/>
+                <a:ea typeface="+mn-ea"/>
+                <a:cs typeface="+mn-cs"/>
+              </a:defRPr>
+            </a:lvl4pPr>
+            <a:lvl5pPr marL="1828800" indent="0" algn="l" defTabSz="914400" rtl="0" eaLnBrk="1" latinLnBrk="0" hangingPunct="1">
+              <a:lnSpc>
+                <a:spcPct val="90000"/>
+              </a:lnSpc>
+              <a:spcBef>
+                <a:spcPts val="500"/>
+              </a:spcBef>
+              <a:buClr>
+                <a:srgbClr val="2E7A40"/>
+              </a:buClr>
+              <a:buFont typeface="Arial" panose="020B0604020202020204" pitchFamily="34" charset="0"/>
+              <a:buNone/>
+              <a:defRPr lang="en-IN" sz="1600" kern="1200">
+                <a:solidFill>
+                  <a:schemeClr val="tx1">
+                    <a:tint val="75000"/>
+                  </a:schemeClr>
+                </a:solidFill>
+                <a:latin typeface="+mn-lt"/>
+                <a:ea typeface="+mn-ea"/>
+                <a:cs typeface="+mn-cs"/>
+              </a:defRPr>
+            </a:lvl5pPr>
+            <a:lvl6pPr marL="2286000" indent="0" algn="l" defTabSz="914400" rtl="0" eaLnBrk="1" latinLnBrk="0" hangingPunct="1">
+              <a:lnSpc>
+                <a:spcPct val="90000"/>
+              </a:lnSpc>
+              <a:spcBef>
+                <a:spcPts val="500"/>
+              </a:spcBef>
+              <a:buFont typeface="Arial" panose="020B0604020202020204" pitchFamily="34" charset="0"/>
+              <a:buNone/>
+              <a:defRPr sz="1600" kern="1200">
+                <a:solidFill>
+                  <a:schemeClr val="tx1">
+                    <a:tint val="75000"/>
+                  </a:schemeClr>
+                </a:solidFill>
+                <a:latin typeface="+mn-lt"/>
+                <a:ea typeface="+mn-ea"/>
+                <a:cs typeface="+mn-cs"/>
+              </a:defRPr>
+            </a:lvl6pPr>
+            <a:lvl7pPr marL="2743200" indent="0" algn="l" defTabSz="914400" rtl="0" eaLnBrk="1" latinLnBrk="0" hangingPunct="1">
+              <a:lnSpc>
+                <a:spcPct val="90000"/>
+              </a:lnSpc>
+              <a:spcBef>
+                <a:spcPts val="500"/>
+              </a:spcBef>
+              <a:buFont typeface="Arial" panose="020B0604020202020204" pitchFamily="34" charset="0"/>
+              <a:buNone/>
+              <a:defRPr sz="1600" kern="1200">
+                <a:solidFill>
+                  <a:schemeClr val="tx1">
+                    <a:tint val="75000"/>
+                  </a:schemeClr>
+                </a:solidFill>
+                <a:latin typeface="+mn-lt"/>
+                <a:ea typeface="+mn-ea"/>
+                <a:cs typeface="+mn-cs"/>
+              </a:defRPr>
+            </a:lvl7pPr>
+            <a:lvl8pPr marL="3200400" indent="0" algn="l" defTabSz="914400" rtl="0" eaLnBrk="1" latinLnBrk="0" hangingPunct="1">
+              <a:lnSpc>
+                <a:spcPct val="90000"/>
+              </a:lnSpc>
+              <a:spcBef>
+                <a:spcPts val="500"/>
+              </a:spcBef>
+              <a:buFont typeface="Arial" panose="020B0604020202020204" pitchFamily="34" charset="0"/>
+              <a:buNone/>
+              <a:defRPr sz="1600" kern="1200">
+                <a:solidFill>
+                  <a:schemeClr val="tx1">
+                    <a:tint val="75000"/>
+                  </a:schemeClr>
+                </a:solidFill>
+                <a:latin typeface="+mn-lt"/>
+                <a:ea typeface="+mn-ea"/>
+                <a:cs typeface="+mn-cs"/>
+              </a:defRPr>
+            </a:lvl8pPr>
+            <a:lvl9pPr marL="3657600" indent="0" algn="l" defTabSz="914400" rtl="0" eaLnBrk="1" latinLnBrk="0" hangingPunct="1">
+              <a:lnSpc>
+                <a:spcPct val="90000"/>
+              </a:lnSpc>
+              <a:spcBef>
+                <a:spcPts val="500"/>
+              </a:spcBef>
+              <a:buFont typeface="Arial" panose="020B0604020202020204" pitchFamily="34" charset="0"/>
+              <a:buNone/>
+              <a:defRPr sz="1600" kern="1200">
+                <a:solidFill>
+                  <a:schemeClr val="tx1">
+                    <a:tint val="75000"/>
+                  </a:schemeClr>
+                </a:solidFill>
+                <a:latin typeface="+mn-lt"/>
+                <a:ea typeface="+mn-ea"/>
+                <a:cs typeface="+mn-cs"/>
+              </a:defRPr>
+            </a:lvl9pPr>
+          </a:lstStyle>
+          <a:p>
+            <a:r>
+              <a:rPr lang="ru-RU" sz="2200" dirty="0"/>
+              <a:t>✔️ Поможет сделать ваш тест</a:t>
+            </a:r>
+          </a:p>
+          <a:p>
+            <a:r>
+              <a:rPr lang="ru-RU" sz="2200" dirty="0"/>
+              <a:t>✔️ Сделает каждому индивидуальный </a:t>
+            </a:r>
+            <a:r>
+              <a:rPr lang="ru-RU" sz="2200" dirty="0">
+                <a:solidFill>
+                  <a:srgbClr val="3F3F3F"/>
+                </a:solidFill>
+              </a:rPr>
+              <a:t>результат</a:t>
+            </a:r>
+            <a:r>
+              <a:rPr lang="ru-RU" sz="2200" dirty="0"/>
+              <a:t> на основе ответов в пройденном тесте.</a:t>
+            </a:r>
+          </a:p>
+          <a:p>
+            <a:r>
+              <a:rPr lang="ru-RU" sz="2200" dirty="0"/>
+              <a:t>✔️ Бесплатный</a:t>
+            </a:r>
+          </a:p>
+          <a:p>
+            <a:r>
+              <a:rPr lang="ru-RU" sz="2200" dirty="0"/>
+              <a:t>✔️ Удобный интерфейс</a:t>
+            </a:r>
+          </a:p>
+          <a:p>
+            <a:r>
+              <a:rPr lang="ru-RU" sz="2200" dirty="0"/>
+              <a:t>✔️ Сохранение результатов</a:t>
+            </a:r>
+          </a:p>
+        </p:txBody>
+      </p:sp>
     </p:spTree>
     <p:extLst>
       <p:ext uri="{BB962C8B-B14F-4D97-AF65-F5344CB8AC3E}">
-        <p14:creationId xmlns:p14="http://schemas.microsoft.com/office/powerpoint/2010/main" val="3891516162"/>
+        <p14:creationId xmlns:p14="http://schemas.microsoft.com/office/powerpoint/2010/main" val="630279023"/>
       </p:ext>
     </p:extLst>
   </p:cSld>
@@ -13667,10 +13528,40 @@
       </p:grpSpPr>
       <p:sp>
         <p:nvSpPr>
-          <p:cNvPr id="2" name="Заголовок 1">
-            <a:extLst>
-              <a:ext uri="{FF2B5EF4-FFF2-40B4-BE49-F238E27FC236}">
-                <a16:creationId xmlns:a16="http://schemas.microsoft.com/office/drawing/2014/main" id="{9DED2AD5-5924-4E02-824F-0408286B998D}"/>
+          <p:cNvPr id="3" name="Номер слайда 2">
+            <a:extLst>
+              <a:ext uri="{FF2B5EF4-FFF2-40B4-BE49-F238E27FC236}">
+                <a16:creationId xmlns:a16="http://schemas.microsoft.com/office/drawing/2014/main" id="{BEF7EF3E-4937-44D7-BB92-050DAC449177}"/>
+              </a:ext>
+            </a:extLst>
+          </p:cNvPr>
+          <p:cNvSpPr>
+            <a:spLocks noGrp="1"/>
+          </p:cNvSpPr>
+          <p:nvPr>
+            <p:ph type="sldNum" sz="quarter" idx="18"/>
+          </p:nvPr>
+        </p:nvSpPr>
+        <p:spPr/>
+        <p:txBody>
+          <a:bodyPr/>
+          <a:lstStyle/>
+          <a:p>
+            <a:pPr rtl="0"/>
+            <a:fld id="{8699F50C-BE38-4BD0-BA84-9B090E1F2B9B}" type="slidenum">
+              <a:rPr lang="ru-RU" noProof="0" smtClean="0"/>
+              <a:t>3</a:t>
+            </a:fld>
+            <a:endParaRPr lang="ru-RU" noProof="0" dirty="0"/>
+          </a:p>
+        </p:txBody>
+      </p:sp>
+      <p:sp>
+        <p:nvSpPr>
+          <p:cNvPr id="4" name="Заголовок 3">
+            <a:extLst>
+              <a:ext uri="{FF2B5EF4-FFF2-40B4-BE49-F238E27FC236}">
+                <a16:creationId xmlns:a16="http://schemas.microsoft.com/office/drawing/2014/main" id="{E783CBC0-4A9E-464E-A561-63E9814FD519}"/>
               </a:ext>
             </a:extLst>
           </p:cNvPr>
@@ -13683,8 +13574,8 @@
         </p:nvSpPr>
         <p:spPr>
           <a:xfrm>
-            <a:off x="1198267" y="2195082"/>
-            <a:ext cx="3995918" cy="1789855"/>
+            <a:off x="518678" y="681037"/>
+            <a:ext cx="8333222" cy="675960"/>
           </a:xfrm>
         </p:spPr>
         <p:txBody>
@@ -13692,26 +13583,18 @@
           <a:lstStyle/>
           <a:p>
             <a:r>
-              <a:rPr lang="en-US" dirty="0" err="1"/>
-              <a:t>TastyAI</a:t>
-            </a:r>
-            <a:r>
-              <a:rPr lang="en-US" dirty="0"/>
-              <a:t> – </a:t>
-            </a:r>
-            <a:r>
               <a:rPr lang="ru-RU" dirty="0"/>
-              <a:t>онлайн тесты с ИИ</a:t>
+              <a:t>Упрощение жизни</a:t>
             </a:r>
           </a:p>
         </p:txBody>
       </p:sp>
       <p:sp>
         <p:nvSpPr>
-          <p:cNvPr id="3" name="Текст 2">
-            <a:extLst>
-              <a:ext uri="{FF2B5EF4-FFF2-40B4-BE49-F238E27FC236}">
-                <a16:creationId xmlns:a16="http://schemas.microsoft.com/office/drawing/2014/main" id="{25411CA9-89E5-4FD9-95E7-36230AD1331C}"/>
+          <p:cNvPr id="5" name="Объект 4">
+            <a:extLst>
+              <a:ext uri="{FF2B5EF4-FFF2-40B4-BE49-F238E27FC236}">
+                <a16:creationId xmlns:a16="http://schemas.microsoft.com/office/drawing/2014/main" id="{9FCF620E-DF78-4257-B94D-DCCB7A320297}"/>
               </a:ext>
             </a:extLst>
           </p:cNvPr>
@@ -13719,64 +13602,153 @@
             <a:spLocks noGrp="1"/>
           </p:cNvSpPr>
           <p:nvPr>
-            <p:ph type="body" idx="1"/>
+            <p:ph idx="1"/>
           </p:nvPr>
         </p:nvSpPr>
         <p:spPr>
           <a:xfrm>
-            <a:off x="461782" y="3984937"/>
-            <a:ext cx="5468887" cy="1940734"/>
+            <a:off x="518678" y="1671924"/>
+            <a:ext cx="7182004" cy="4505039"/>
           </a:xfrm>
         </p:spPr>
         <p:txBody>
-          <a:bodyPr>
-            <a:noAutofit/>
-          </a:bodyPr>
+          <a:bodyPr/>
           <a:lstStyle/>
           <a:p>
-            <a:r>
-              <a:rPr lang="ru-RU" sz="2700" dirty="0"/>
-              <a:t>- это абсолютно бесплатный сайт с тестами где используется искусственный интеллект для ваших разных задач в области тестов.</a:t>
+            <a:pPr algn="l"/>
+            <a:r>
+              <a:rPr lang="ru-RU" sz="2400" b="0" i="0" dirty="0">
+                <a:solidFill>
+                  <a:srgbClr val="3F3F3F"/>
+                </a:solidFill>
+                <a:effectLst/>
+              </a:rPr>
+              <a:t>	</a:t>
+            </a:r>
+            <a:r>
+              <a:rPr lang="ru-RU" sz="2400" b="0" i="0" dirty="0" err="1">
+                <a:solidFill>
+                  <a:srgbClr val="3F3F3F"/>
+                </a:solidFill>
+                <a:effectLst/>
+              </a:rPr>
+              <a:t>TastyAI</a:t>
+            </a:r>
+            <a:r>
+              <a:rPr lang="ru-RU" sz="2400" b="0" i="0" dirty="0">
+                <a:solidFill>
+                  <a:srgbClr val="3F3F3F"/>
+                </a:solidFill>
+                <a:effectLst/>
+              </a:rPr>
+              <a:t> экономит ваше время и позволяет создавать профессиональные онлайн-тесты в несколько кликов.</a:t>
+            </a:r>
+          </a:p>
+          <a:p>
+            <a:pPr algn="l"/>
+            <a:r>
+              <a:rPr lang="ru-RU" sz="2400" dirty="0">
+                <a:solidFill>
+                  <a:srgbClr val="3F3F3F"/>
+                </a:solidFill>
+              </a:rPr>
+              <a:t>	</a:t>
+            </a:r>
+            <a:r>
+              <a:rPr lang="ru-RU" sz="2400" b="0" i="0" dirty="0">
+                <a:solidFill>
+                  <a:srgbClr val="3F3F3F"/>
+                </a:solidFill>
+                <a:effectLst/>
+              </a:rPr>
+              <a:t>Вместо шаблонного результата, </a:t>
+            </a:r>
+            <a:r>
+              <a:rPr lang="ru-RU" sz="2400" b="0" i="0" dirty="0" err="1">
+                <a:solidFill>
+                  <a:srgbClr val="3F3F3F"/>
+                </a:solidFill>
+                <a:effectLst/>
+              </a:rPr>
+              <a:t>TastyAI</a:t>
+            </a:r>
+            <a:r>
+              <a:rPr lang="ru-RU" sz="2400" b="0" i="0" dirty="0">
+                <a:solidFill>
+                  <a:srgbClr val="3F3F3F"/>
+                </a:solidFill>
+                <a:effectLst/>
+              </a:rPr>
+              <a:t> предоставляет каждому пользователю индивидуальный отчет, основанный на анализе его ответов с помощью искусственного интеллекта.</a:t>
+            </a:r>
+          </a:p>
+          <a:p>
+            <a:pPr algn="l"/>
+            <a:r>
+              <a:rPr lang="ru-RU" sz="2400" b="0" i="0" dirty="0">
+                <a:solidFill>
+                  <a:srgbClr val="3F3F3F"/>
+                </a:solidFill>
+                <a:effectLst/>
+              </a:rPr>
+              <a:t>	Наша технология позволяет выявить не только уровень знаний, но и сильные и слабые стороны каждого пользователя, что делает обучение более эффективным.</a:t>
             </a:r>
           </a:p>
         </p:txBody>
       </p:sp>
       <p:pic>
         <p:nvPicPr>
-          <p:cNvPr id="9" name="Рисунок 8">
-            <a:extLst>
-              <a:ext uri="{FF2B5EF4-FFF2-40B4-BE49-F238E27FC236}">
-                <a16:creationId xmlns:a16="http://schemas.microsoft.com/office/drawing/2014/main" id="{D6B7648D-348E-423A-A9F8-14BE77953C78}"/>
+          <p:cNvPr id="2052" name="Picture 4" descr="Picture background">
+            <a:extLst>
+              <a:ext uri="{FF2B5EF4-FFF2-40B4-BE49-F238E27FC236}">
+                <a16:creationId xmlns:a16="http://schemas.microsoft.com/office/drawing/2014/main" id="{28643BC2-38B6-40F4-8EC7-1AA30A1B1B59}"/>
               </a:ext>
             </a:extLst>
           </p:cNvPr>
           <p:cNvPicPr>
-            <a:picLocks noChangeAspect="1"/>
+            <a:picLocks noChangeAspect="1" noChangeArrowheads="1"/>
           </p:cNvPicPr>
           <p:nvPr/>
         </p:nvPicPr>
         <p:blipFill>
-          <a:blip r:embed="rId2"/>
+          <a:blip r:embed="rId2">
+            <a:extLst>
+              <a:ext uri="{28A0092B-C50C-407E-A947-70E740481C1C}">
+                <a14:useLocalDpi xmlns:a14="http://schemas.microsoft.com/office/drawing/2010/main" val="0"/>
+              </a:ext>
+            </a:extLst>
+          </a:blip>
+          <a:srcRect/>
           <a:stretch>
             <a:fillRect/>
           </a:stretch>
         </p:blipFill>
-        <p:spPr>
+        <p:spPr bwMode="auto">
           <a:xfrm>
-            <a:off x="122974" y="660345"/>
-            <a:ext cx="5734971" cy="1597080"/>
+            <a:off x="7837393" y="2716305"/>
+            <a:ext cx="3180229" cy="3180229"/>
           </a:xfrm>
           <a:prstGeom prst="rect">
             <a:avLst/>
           </a:prstGeom>
+          <a:noFill/>
+          <a:extLst>
+            <a:ext uri="{909E8E84-426E-40DD-AFC4-6F175D3DCCD1}">
+              <a14:hiddenFill xmlns:a14="http://schemas.microsoft.com/office/drawing/2010/main">
+                <a:solidFill>
+                  <a:srgbClr val="FFFFFF"/>
+                </a:solidFill>
+              </a14:hiddenFill>
+            </a:ext>
+          </a:extLst>
         </p:spPr>
       </p:pic>
       <p:sp>
         <p:nvSpPr>
-          <p:cNvPr id="13" name="Нижний колонтитул 1">
-            <a:extLst>
-              <a:ext uri="{FF2B5EF4-FFF2-40B4-BE49-F238E27FC236}">
-                <a16:creationId xmlns:a16="http://schemas.microsoft.com/office/drawing/2014/main" id="{46CE1A0C-FB01-4D4F-A11A-1B495307CAC2}"/>
+          <p:cNvPr id="8" name="Нижний колонтитул 1">
+            <a:extLst>
+              <a:ext uri="{FF2B5EF4-FFF2-40B4-BE49-F238E27FC236}">
+                <a16:creationId xmlns:a16="http://schemas.microsoft.com/office/drawing/2014/main" id="{ECB7ACD2-65AC-4D2D-A47D-33A14E2C1819}"/>
               </a:ext>
             </a:extLst>
           </p:cNvPr>
@@ -13900,276 +13872,10 @@
           </a:p>
         </p:txBody>
       </p:sp>
-      <p:sp>
-        <p:nvSpPr>
-          <p:cNvPr id="7" name="Объект 4">
-            <a:extLst>
-              <a:ext uri="{FF2B5EF4-FFF2-40B4-BE49-F238E27FC236}">
-                <a16:creationId xmlns:a16="http://schemas.microsoft.com/office/drawing/2014/main" id="{B7AC610B-A440-4F80-B128-587794215A34}"/>
-              </a:ext>
-            </a:extLst>
-          </p:cNvPr>
-          <p:cNvSpPr txBox="1">
-            <a:spLocks/>
-          </p:cNvSpPr>
-          <p:nvPr/>
-        </p:nvSpPr>
-        <p:spPr>
-          <a:xfrm>
-            <a:off x="6096000" y="3429000"/>
-            <a:ext cx="5997388" cy="4505039"/>
-          </a:xfrm>
-          <a:prstGeom prst="rect">
-            <a:avLst/>
-          </a:prstGeom>
-        </p:spPr>
-        <p:txBody>
-          <a:bodyPr rtlCol="0">
-            <a:normAutofit/>
-          </a:bodyPr>
-          <a:lstStyle>
-            <a:lvl1pPr marL="0" indent="0" algn="l" defTabSz="914400" rtl="0" eaLnBrk="1" latinLnBrk="0" hangingPunct="1">
-              <a:lnSpc>
-                <a:spcPct val="90000"/>
-              </a:lnSpc>
-              <a:spcBef>
-                <a:spcPts val="1000"/>
-              </a:spcBef>
-              <a:buClr>
-                <a:srgbClr val="2E7A40"/>
-              </a:buClr>
-              <a:buFont typeface="Arial" panose="020B0604020202020204" pitchFamily="34" charset="0"/>
-              <a:buNone/>
-              <a:defRPr lang="en-US" sz="2000" b="0" i="0" kern="1200" spc="300">
-                <a:solidFill>
-                  <a:schemeClr val="accent6"/>
-                </a:solidFill>
-                <a:latin typeface="+mn-lt"/>
-                <a:ea typeface="+mn-ea"/>
-                <a:cs typeface="Calibri" panose="020F0502020204030204" pitchFamily="34" charset="0"/>
-              </a:defRPr>
-            </a:lvl1pPr>
-            <a:lvl2pPr marL="457200" indent="0" algn="l" defTabSz="914400" rtl="0" eaLnBrk="1" latinLnBrk="0" hangingPunct="1">
-              <a:lnSpc>
-                <a:spcPct val="90000"/>
-              </a:lnSpc>
-              <a:spcBef>
-                <a:spcPts val="500"/>
-              </a:spcBef>
-              <a:buClr>
-                <a:srgbClr val="2E7A40"/>
-              </a:buClr>
-              <a:buFont typeface="Arial" panose="020B0604020202020204" pitchFamily="34" charset="0"/>
-              <a:buNone/>
-              <a:defRPr lang="en-US" sz="2000" kern="1200">
-                <a:solidFill>
-                  <a:schemeClr val="tx1">
-                    <a:tint val="75000"/>
-                  </a:schemeClr>
-                </a:solidFill>
-                <a:latin typeface="+mn-lt"/>
-                <a:ea typeface="+mn-ea"/>
-                <a:cs typeface="+mn-cs"/>
-              </a:defRPr>
-            </a:lvl2pPr>
-            <a:lvl3pPr marL="914400" indent="0" algn="l" defTabSz="914400" rtl="0" eaLnBrk="1" latinLnBrk="0" hangingPunct="1">
-              <a:lnSpc>
-                <a:spcPct val="90000"/>
-              </a:lnSpc>
-              <a:spcBef>
-                <a:spcPts val="500"/>
-              </a:spcBef>
-              <a:buClr>
-                <a:srgbClr val="2E7A40"/>
-              </a:buClr>
-              <a:buFont typeface="Arial" panose="020B0604020202020204" pitchFamily="34" charset="0"/>
-              <a:buNone/>
-              <a:defRPr lang="en-US" sz="1800" kern="1200">
-                <a:solidFill>
-                  <a:schemeClr val="tx1">
-                    <a:tint val="75000"/>
-                  </a:schemeClr>
-                </a:solidFill>
-                <a:latin typeface="+mn-lt"/>
-                <a:ea typeface="+mn-ea"/>
-                <a:cs typeface="+mn-cs"/>
-              </a:defRPr>
-            </a:lvl3pPr>
-            <a:lvl4pPr marL="1371600" indent="0" algn="l" defTabSz="914400" rtl="0" eaLnBrk="1" latinLnBrk="0" hangingPunct="1">
-              <a:lnSpc>
-                <a:spcPct val="90000"/>
-              </a:lnSpc>
-              <a:spcBef>
-                <a:spcPts val="500"/>
-              </a:spcBef>
-              <a:buClr>
-                <a:srgbClr val="2E7A40"/>
-              </a:buClr>
-              <a:buFont typeface="Arial" panose="020B0604020202020204" pitchFamily="34" charset="0"/>
-              <a:buNone/>
-              <a:defRPr lang="en-US" sz="1600" kern="1200">
-                <a:solidFill>
-                  <a:schemeClr val="tx1">
-                    <a:tint val="75000"/>
-                  </a:schemeClr>
-                </a:solidFill>
-                <a:latin typeface="+mn-lt"/>
-                <a:ea typeface="+mn-ea"/>
-                <a:cs typeface="+mn-cs"/>
-              </a:defRPr>
-            </a:lvl4pPr>
-            <a:lvl5pPr marL="1828800" indent="0" algn="l" defTabSz="914400" rtl="0" eaLnBrk="1" latinLnBrk="0" hangingPunct="1">
-              <a:lnSpc>
-                <a:spcPct val="90000"/>
-              </a:lnSpc>
-              <a:spcBef>
-                <a:spcPts val="500"/>
-              </a:spcBef>
-              <a:buClr>
-                <a:srgbClr val="2E7A40"/>
-              </a:buClr>
-              <a:buFont typeface="Arial" panose="020B0604020202020204" pitchFamily="34" charset="0"/>
-              <a:buNone/>
-              <a:defRPr lang="en-IN" sz="1600" kern="1200">
-                <a:solidFill>
-                  <a:schemeClr val="tx1">
-                    <a:tint val="75000"/>
-                  </a:schemeClr>
-                </a:solidFill>
-                <a:latin typeface="+mn-lt"/>
-                <a:ea typeface="+mn-ea"/>
-                <a:cs typeface="+mn-cs"/>
-              </a:defRPr>
-            </a:lvl5pPr>
-            <a:lvl6pPr marL="2286000" indent="0" algn="l" defTabSz="914400" rtl="0" eaLnBrk="1" latinLnBrk="0" hangingPunct="1">
-              <a:lnSpc>
-                <a:spcPct val="90000"/>
-              </a:lnSpc>
-              <a:spcBef>
-                <a:spcPts val="500"/>
-              </a:spcBef>
-              <a:buFont typeface="Arial" panose="020B0604020202020204" pitchFamily="34" charset="0"/>
-              <a:buNone/>
-              <a:defRPr sz="1600" kern="1200">
-                <a:solidFill>
-                  <a:schemeClr val="tx1">
-                    <a:tint val="75000"/>
-                  </a:schemeClr>
-                </a:solidFill>
-                <a:latin typeface="+mn-lt"/>
-                <a:ea typeface="+mn-ea"/>
-                <a:cs typeface="+mn-cs"/>
-              </a:defRPr>
-            </a:lvl6pPr>
-            <a:lvl7pPr marL="2743200" indent="0" algn="l" defTabSz="914400" rtl="0" eaLnBrk="1" latinLnBrk="0" hangingPunct="1">
-              <a:lnSpc>
-                <a:spcPct val="90000"/>
-              </a:lnSpc>
-              <a:spcBef>
-                <a:spcPts val="500"/>
-              </a:spcBef>
-              <a:buFont typeface="Arial" panose="020B0604020202020204" pitchFamily="34" charset="0"/>
-              <a:buNone/>
-              <a:defRPr sz="1600" kern="1200">
-                <a:solidFill>
-                  <a:schemeClr val="tx1">
-                    <a:tint val="75000"/>
-                  </a:schemeClr>
-                </a:solidFill>
-                <a:latin typeface="+mn-lt"/>
-                <a:ea typeface="+mn-ea"/>
-                <a:cs typeface="+mn-cs"/>
-              </a:defRPr>
-            </a:lvl7pPr>
-            <a:lvl8pPr marL="3200400" indent="0" algn="l" defTabSz="914400" rtl="0" eaLnBrk="1" latinLnBrk="0" hangingPunct="1">
-              <a:lnSpc>
-                <a:spcPct val="90000"/>
-              </a:lnSpc>
-              <a:spcBef>
-                <a:spcPts val="500"/>
-              </a:spcBef>
-              <a:buFont typeface="Arial" panose="020B0604020202020204" pitchFamily="34" charset="0"/>
-              <a:buNone/>
-              <a:defRPr sz="1600" kern="1200">
-                <a:solidFill>
-                  <a:schemeClr val="tx1">
-                    <a:tint val="75000"/>
-                  </a:schemeClr>
-                </a:solidFill>
-                <a:latin typeface="+mn-lt"/>
-                <a:ea typeface="+mn-ea"/>
-                <a:cs typeface="+mn-cs"/>
-              </a:defRPr>
-            </a:lvl8pPr>
-            <a:lvl9pPr marL="3657600" indent="0" algn="l" defTabSz="914400" rtl="0" eaLnBrk="1" latinLnBrk="0" hangingPunct="1">
-              <a:lnSpc>
-                <a:spcPct val="90000"/>
-              </a:lnSpc>
-              <a:spcBef>
-                <a:spcPts val="500"/>
-              </a:spcBef>
-              <a:buFont typeface="Arial" panose="020B0604020202020204" pitchFamily="34" charset="0"/>
-              <a:buNone/>
-              <a:defRPr sz="1600" kern="1200">
-                <a:solidFill>
-                  <a:schemeClr val="tx1">
-                    <a:tint val="75000"/>
-                  </a:schemeClr>
-                </a:solidFill>
-                <a:latin typeface="+mn-lt"/>
-                <a:ea typeface="+mn-ea"/>
-                <a:cs typeface="+mn-cs"/>
-              </a:defRPr>
-            </a:lvl9pPr>
-          </a:lstStyle>
-          <a:p>
-            <a:r>
-              <a:rPr lang="ru-RU" sz="2200" dirty="0"/>
-              <a:t>✔️ Поможет сделать ваш тест</a:t>
-            </a:r>
-          </a:p>
-          <a:p>
-            <a:r>
-              <a:rPr lang="ru-RU" sz="2200" dirty="0"/>
-              <a:t>✔️ Сделает каждому индивидуальный </a:t>
-            </a:r>
-            <a:r>
-              <a:rPr lang="ru-RU" sz="2200" dirty="0">
-                <a:solidFill>
-                  <a:srgbClr val="3F3F3F"/>
-                </a:solidFill>
-              </a:rPr>
-              <a:t>результат</a:t>
-            </a:r>
-            <a:r>
-              <a:rPr lang="ru-RU" sz="2200" dirty="0"/>
-              <a:t> на основе ответов в пройденном тесте.</a:t>
-            </a:r>
-          </a:p>
-          <a:p>
-            <a:r>
-              <a:rPr lang="ru-RU" sz="2200" dirty="0"/>
-              <a:t>✔️ Бесплатный</a:t>
-            </a:r>
-          </a:p>
-          <a:p>
-            <a:r>
-              <a:rPr lang="ru-RU" sz="2200" dirty="0"/>
-              <a:t>✔️ Удобный интерфейс</a:t>
-            </a:r>
-          </a:p>
-          <a:p>
-            <a:r>
-              <a:rPr lang="ru-RU" sz="2200" dirty="0"/>
-              <a:t>✔️ Сохранение результатов</a:t>
-            </a:r>
-          </a:p>
-        </p:txBody>
-      </p:sp>
     </p:spTree>
     <p:extLst>
       <p:ext uri="{BB962C8B-B14F-4D97-AF65-F5344CB8AC3E}">
-        <p14:creationId xmlns:p14="http://schemas.microsoft.com/office/powerpoint/2010/main" val="630279023"/>
+        <p14:creationId xmlns:p14="http://schemas.microsoft.com/office/powerpoint/2010/main" val="3154786798"/>
       </p:ext>
     </p:extLst>
   </p:cSld>
@@ -14198,40 +13904,10 @@
       </p:grpSpPr>
       <p:sp>
         <p:nvSpPr>
-          <p:cNvPr id="3" name="Номер слайда 2">
-            <a:extLst>
-              <a:ext uri="{FF2B5EF4-FFF2-40B4-BE49-F238E27FC236}">
-                <a16:creationId xmlns:a16="http://schemas.microsoft.com/office/drawing/2014/main" id="{BEF7EF3E-4937-44D7-BB92-050DAC449177}"/>
-              </a:ext>
-            </a:extLst>
-          </p:cNvPr>
-          <p:cNvSpPr>
-            <a:spLocks noGrp="1"/>
-          </p:cNvSpPr>
-          <p:nvPr>
-            <p:ph type="sldNum" sz="quarter" idx="18"/>
-          </p:nvPr>
-        </p:nvSpPr>
-        <p:spPr/>
-        <p:txBody>
-          <a:bodyPr/>
-          <a:lstStyle/>
-          <a:p>
-            <a:pPr rtl="0"/>
-            <a:fld id="{8699F50C-BE38-4BD0-BA84-9B090E1F2B9B}" type="slidenum">
-              <a:rPr lang="ru-RU" noProof="0" smtClean="0"/>
-              <a:t>4</a:t>
-            </a:fld>
-            <a:endParaRPr lang="ru-RU" noProof="0" dirty="0"/>
-          </a:p>
-        </p:txBody>
-      </p:sp>
-      <p:sp>
-        <p:nvSpPr>
-          <p:cNvPr id="4" name="Заголовок 3">
-            <a:extLst>
-              <a:ext uri="{FF2B5EF4-FFF2-40B4-BE49-F238E27FC236}">
-                <a16:creationId xmlns:a16="http://schemas.microsoft.com/office/drawing/2014/main" id="{E783CBC0-4A9E-464E-A561-63E9814FD519}"/>
+          <p:cNvPr id="2" name="Заголовок 1">
+            <a:extLst>
+              <a:ext uri="{FF2B5EF4-FFF2-40B4-BE49-F238E27FC236}">
+                <a16:creationId xmlns:a16="http://schemas.microsoft.com/office/drawing/2014/main" id="{ECD53AF3-7ACD-4B83-BE35-7E89C959BDCB}"/>
               </a:ext>
             </a:extLst>
           </p:cNvPr>
@@ -14244,8 +13920,8 @@
         </p:nvSpPr>
         <p:spPr>
           <a:xfrm>
-            <a:off x="518678" y="681037"/>
-            <a:ext cx="8333222" cy="675960"/>
+            <a:off x="6283841" y="1201271"/>
+            <a:ext cx="4911633" cy="639628"/>
           </a:xfrm>
         </p:spPr>
         <p:txBody>
@@ -14254,17 +13930,17 @@
           <a:p>
             <a:r>
               <a:rPr lang="ru-RU" dirty="0"/>
-              <a:t>Упрощение жизни</a:t>
+              <a:t>Пользователи</a:t>
             </a:r>
           </a:p>
         </p:txBody>
       </p:sp>
       <p:sp>
         <p:nvSpPr>
-          <p:cNvPr id="5" name="Объект 4">
-            <a:extLst>
-              <a:ext uri="{FF2B5EF4-FFF2-40B4-BE49-F238E27FC236}">
-                <a16:creationId xmlns:a16="http://schemas.microsoft.com/office/drawing/2014/main" id="{9FCF620E-DF78-4257-B94D-DCCB7A320297}"/>
+          <p:cNvPr id="3" name="Текст 2">
+            <a:extLst>
+              <a:ext uri="{FF2B5EF4-FFF2-40B4-BE49-F238E27FC236}">
+                <a16:creationId xmlns:a16="http://schemas.microsoft.com/office/drawing/2014/main" id="{AF679D59-F3BA-471C-8DE0-68B6F150E0D4}"/>
               </a:ext>
             </a:extLst>
           </p:cNvPr>
@@ -14272,31 +13948,41 @@
             <a:spLocks noGrp="1"/>
           </p:cNvSpPr>
           <p:nvPr>
-            <p:ph idx="1"/>
+            <p:ph type="body" idx="1"/>
           </p:nvPr>
         </p:nvSpPr>
         <p:spPr>
           <a:xfrm>
-            <a:off x="518678" y="1671924"/>
-            <a:ext cx="7182004" cy="4505039"/>
+            <a:off x="6283841" y="1954281"/>
+            <a:ext cx="5289593" cy="4222401"/>
           </a:xfrm>
         </p:spPr>
         <p:txBody>
-          <a:bodyPr/>
+          <a:bodyPr>
+            <a:normAutofit fontScale="70000" lnSpcReduction="20000"/>
+          </a:bodyPr>
           <a:lstStyle/>
           <a:p>
             <a:pPr algn="l"/>
             <a:r>
-              <a:rPr lang="ru-RU" sz="2400" b="0" i="0" dirty="0">
+              <a:rPr lang="ru-RU" sz="3000" b="0" i="0" dirty="0">
                 <a:solidFill>
                   <a:srgbClr val="3F3F3F"/>
                 </a:solidFill>
                 <a:effectLst/>
               </a:rPr>
-              <a:t>	</a:t>
-            </a:r>
-            <a:r>
-              <a:rPr lang="ru-RU" sz="2400" b="0" i="0" dirty="0" err="1">
+              <a:t>Мы планируем </a:t>
+            </a:r>
+            <a:r>
+              <a:rPr lang="ru-RU" sz="3000" dirty="0">
+                <a:solidFill>
+                  <a:srgbClr val="3F3F3F"/>
+                </a:solidFill>
+              </a:rPr>
+              <a:t>запустить </a:t>
+            </a:r>
+            <a:r>
+              <a:rPr lang="ru-RU" sz="3000" b="0" i="0" dirty="0" err="1">
                 <a:solidFill>
                   <a:srgbClr val="3F3F3F"/>
                 </a:solidFill>
@@ -14305,80 +13991,101 @@
               <a:t>TastyAI</a:t>
             </a:r>
             <a:r>
-              <a:rPr lang="ru-RU" sz="2400" b="0" i="0" dirty="0">
+              <a:rPr lang="ru-RU" sz="3000" b="0" i="0" dirty="0">
                 <a:solidFill>
                   <a:srgbClr val="3F3F3F"/>
                 </a:solidFill>
                 <a:effectLst/>
               </a:rPr>
-              <a:t> экономит ваше время и позволяет создавать профессиональные онлайн-тесты в несколько кликов.</a:t>
-            </a:r>
-          </a:p>
-          <a:p>
-            <a:pPr algn="l"/>
-            <a:r>
-              <a:rPr lang="ru-RU" sz="2400" dirty="0">
+              <a:t> </a:t>
+            </a:r>
+            <a:r>
+              <a:rPr lang="ru-RU" sz="3000" dirty="0">
                 <a:solidFill>
                   <a:srgbClr val="3F3F3F"/>
                 </a:solidFill>
               </a:rPr>
-              <a:t>	</a:t>
-            </a:r>
-            <a:r>
-              <a:rPr lang="ru-RU" sz="2400" b="0" i="0" dirty="0">
+              <a:t>на </a:t>
+            </a:r>
+            <a:r>
+              <a:rPr lang="ru-RU" sz="3000" b="0" i="0" dirty="0">
                 <a:solidFill>
                   <a:srgbClr val="3F3F3F"/>
                 </a:solidFill>
                 <a:effectLst/>
               </a:rPr>
-              <a:t>Вместо шаблонного результата, </a:t>
-            </a:r>
-            <a:r>
-              <a:rPr lang="ru-RU" sz="2400" b="0" i="0" dirty="0" err="1">
+              <a:t>сервере со своим доменом, чтобы сделать его доступным для еще большего числа пользователей.</a:t>
+            </a:r>
+          </a:p>
+          <a:p>
+            <a:pPr algn="l"/>
+            <a:r>
+              <a:rPr lang="ru-RU" sz="3000" dirty="0">
+                <a:solidFill>
+                  <a:srgbClr val="3F3F3F"/>
+                </a:solidFill>
+              </a:rPr>
+              <a:t>В том числе будут учителя и их ученики.</a:t>
+            </a:r>
+          </a:p>
+          <a:p>
+            <a:pPr algn="l"/>
+            <a:r>
+              <a:rPr lang="ru-RU" sz="3000" b="0" i="0" dirty="0">
                 <a:solidFill>
                   <a:srgbClr val="3F3F3F"/>
                 </a:solidFill>
                 <a:effectLst/>
               </a:rPr>
-              <a:t>TastyAI</a:t>
-            </a:r>
-            <a:r>
-              <a:rPr lang="ru-RU" sz="2400" b="0" i="0" dirty="0">
+              <a:t>Учителям к примеру это поможет изучить уровень знаний детей и их слабые стороны, а также тратить меньше времени на проверку и создание тестов.</a:t>
+            </a:r>
+          </a:p>
+          <a:p>
+            <a:pPr algn="l"/>
+            <a:r>
+              <a:rPr lang="ru-RU" sz="3000" b="0" i="0" dirty="0">
                 <a:solidFill>
                   <a:srgbClr val="3F3F3F"/>
                 </a:solidFill>
                 <a:effectLst/>
               </a:rPr>
-              <a:t> предоставляет каждому пользователю индивидуальный отчет, основанный на анализе его ответов с помощью искусственного интеллекта.</a:t>
-            </a:r>
-          </a:p>
-          <a:p>
-            <a:pPr algn="l"/>
-            <a:r>
-              <a:rPr lang="ru-RU" sz="2400" b="0" i="0" dirty="0">
+              <a:t>Создани</a:t>
+            </a:r>
+            <a:r>
+              <a:rPr lang="ru-RU" sz="3000" dirty="0">
                 <a:solidFill>
                   <a:srgbClr val="3F3F3F"/>
                 </a:solidFill>
-                <a:effectLst/>
               </a:rPr>
-              <a:t>	Наша технология позволяет выявить не только уровень знаний, но и сильные и слабые стороны каждого пользователя, что делает обучение более эффективным.</a:t>
-            </a:r>
+              <a:t>е сайтов с помощью ИИ поможет сделать много новых различных тестов, которые будут автоматически проверены.</a:t>
+            </a:r>
+            <a:endParaRPr lang="ru-RU" sz="3000" b="0" i="0" dirty="0">
+              <a:solidFill>
+                <a:srgbClr val="3F3F3F"/>
+              </a:solidFill>
+              <a:effectLst/>
+            </a:endParaRPr>
+          </a:p>
+          <a:p>
+            <a:endParaRPr lang="ru-RU" dirty="0"/>
           </a:p>
         </p:txBody>
       </p:sp>
       <p:pic>
         <p:nvPicPr>
-          <p:cNvPr id="2052" name="Picture 4" descr="Picture background">
-            <a:extLst>
-              <a:ext uri="{FF2B5EF4-FFF2-40B4-BE49-F238E27FC236}">
-                <a16:creationId xmlns:a16="http://schemas.microsoft.com/office/drawing/2014/main" id="{28643BC2-38B6-40F4-8EC7-1AA30A1B1B59}"/>
+          <p:cNvPr id="1026" name="Picture 2" descr="Picture background">
+            <a:extLst>
+              <a:ext uri="{FF2B5EF4-FFF2-40B4-BE49-F238E27FC236}">
+                <a16:creationId xmlns:a16="http://schemas.microsoft.com/office/drawing/2014/main" id="{9CE56B79-4693-48DC-AD76-E497E1F4684E}"/>
               </a:ext>
             </a:extLst>
           </p:cNvPr>
           <p:cNvPicPr>
-            <a:picLocks noChangeAspect="1" noChangeArrowheads="1"/>
+            <a:picLocks noGrp="1" noChangeAspect="1" noChangeArrowheads="1"/>
           </p:cNvPicPr>
-          <p:nvPr/>
+          <p:nvPr>
+            <p:ph type="pic" sz="quarter" idx="13"/>
+          </p:nvPr>
         </p:nvPicPr>
         <p:blipFill>
           <a:blip r:embed="rId2">
@@ -14388,16 +14095,12 @@
               </a:ext>
             </a:extLst>
           </a:blip>
-          <a:srcRect/>
+          <a:srcRect l="22870" r="22870"/>
           <a:stretch>
             <a:fillRect/>
           </a:stretch>
         </p:blipFill>
         <p:spPr bwMode="auto">
-          <a:xfrm>
-            <a:off x="7837393" y="2716305"/>
-            <a:ext cx="3180229" cy="3180229"/>
-          </a:xfrm>
           <a:prstGeom prst="rect">
             <a:avLst/>
           </a:prstGeom>
@@ -14415,10 +14118,10 @@
       </p:pic>
       <p:sp>
         <p:nvSpPr>
-          <p:cNvPr id="8" name="Нижний колонтитул 1">
-            <a:extLst>
-              <a:ext uri="{FF2B5EF4-FFF2-40B4-BE49-F238E27FC236}">
-                <a16:creationId xmlns:a16="http://schemas.microsoft.com/office/drawing/2014/main" id="{ECB7ACD2-65AC-4D2D-A47D-33A14E2C1819}"/>
+          <p:cNvPr id="5" name="Нижний колонтитул 1">
+            <a:extLst>
+              <a:ext uri="{FF2B5EF4-FFF2-40B4-BE49-F238E27FC236}">
+                <a16:creationId xmlns:a16="http://schemas.microsoft.com/office/drawing/2014/main" id="{071CF5FE-712B-42D7-9C76-355ACCCA140D}"/>
               </a:ext>
             </a:extLst>
           </p:cNvPr>
@@ -14545,7 +14248,7 @@
     </p:spTree>
     <p:extLst>
       <p:ext uri="{BB962C8B-B14F-4D97-AF65-F5344CB8AC3E}">
-        <p14:creationId xmlns:p14="http://schemas.microsoft.com/office/powerpoint/2010/main" val="3154786798"/>
+        <p14:creationId xmlns:p14="http://schemas.microsoft.com/office/powerpoint/2010/main" val="241966745"/>
       </p:ext>
     </p:extLst>
   </p:cSld>
@@ -14574,10 +14277,45 @@
       </p:grpSpPr>
       <p:sp>
         <p:nvSpPr>
-          <p:cNvPr id="2" name="Заголовок 1">
-            <a:extLst>
-              <a:ext uri="{FF2B5EF4-FFF2-40B4-BE49-F238E27FC236}">
-                <a16:creationId xmlns:a16="http://schemas.microsoft.com/office/drawing/2014/main" id="{ECD53AF3-7ACD-4B83-BE35-7E89C959BDCB}"/>
+          <p:cNvPr id="3" name="Номер слайда 2">
+            <a:extLst>
+              <a:ext uri="{FF2B5EF4-FFF2-40B4-BE49-F238E27FC236}">
+                <a16:creationId xmlns:a16="http://schemas.microsoft.com/office/drawing/2014/main" id="{613D1309-5330-4598-97FC-69345EEB1899}"/>
+              </a:ext>
+            </a:extLst>
+          </p:cNvPr>
+          <p:cNvSpPr>
+            <a:spLocks noGrp="1"/>
+          </p:cNvSpPr>
+          <p:nvPr>
+            <p:ph type="sldNum" sz="quarter" idx="18"/>
+          </p:nvPr>
+        </p:nvSpPr>
+        <p:spPr>
+          <a:xfrm>
+            <a:off x="10905026" y="6338017"/>
+            <a:ext cx="740227" cy="365125"/>
+          </a:xfrm>
+        </p:spPr>
+        <p:txBody>
+          <a:bodyPr/>
+          <a:lstStyle/>
+          <a:p>
+            <a:pPr rtl="0"/>
+            <a:fld id="{8699F50C-BE38-4BD0-BA84-9B090E1F2B9B}" type="slidenum">
+              <a:rPr lang="ru-RU" noProof="0" smtClean="0"/>
+              <a:t>5</a:t>
+            </a:fld>
+            <a:endParaRPr lang="ru-RU" noProof="0" dirty="0"/>
+          </a:p>
+        </p:txBody>
+      </p:sp>
+      <p:sp>
+        <p:nvSpPr>
+          <p:cNvPr id="4" name="Заголовок 3">
+            <a:extLst>
+              <a:ext uri="{FF2B5EF4-FFF2-40B4-BE49-F238E27FC236}">
+                <a16:creationId xmlns:a16="http://schemas.microsoft.com/office/drawing/2014/main" id="{B056112C-CEC6-4B47-83E7-7FB5130C01B1}"/>
               </a:ext>
             </a:extLst>
           </p:cNvPr>
@@ -14590,8 +14328,8 @@
         </p:nvSpPr>
         <p:spPr>
           <a:xfrm>
-            <a:off x="6283841" y="1201271"/>
-            <a:ext cx="4911633" cy="639628"/>
+            <a:off x="304802" y="298440"/>
+            <a:ext cx="8333222" cy="777090"/>
           </a:xfrm>
         </p:spPr>
         <p:txBody>
@@ -14600,171 +14338,260 @@
           <a:p>
             <a:r>
               <a:rPr lang="ru-RU" dirty="0"/>
-              <a:t>Пользователи</a:t>
-            </a:r>
-          </a:p>
-        </p:txBody>
-      </p:sp>
-      <p:sp>
-        <p:nvSpPr>
-          <p:cNvPr id="3" name="Текст 2">
-            <a:extLst>
-              <a:ext uri="{FF2B5EF4-FFF2-40B4-BE49-F238E27FC236}">
-                <a16:creationId xmlns:a16="http://schemas.microsoft.com/office/drawing/2014/main" id="{AF679D59-F3BA-471C-8DE0-68B6F150E0D4}"/>
-              </a:ext>
-            </a:extLst>
-          </p:cNvPr>
-          <p:cNvSpPr>
-            <a:spLocks noGrp="1"/>
-          </p:cNvSpPr>
-          <p:nvPr>
-            <p:ph type="body" idx="1"/>
-          </p:nvPr>
-        </p:nvSpPr>
-        <p:spPr>
-          <a:xfrm>
-            <a:off x="6283841" y="1954281"/>
-            <a:ext cx="5289593" cy="4222401"/>
-          </a:xfrm>
-        </p:spPr>
-        <p:txBody>
-          <a:bodyPr>
-            <a:normAutofit fontScale="70000" lnSpcReduction="20000"/>
-          </a:bodyPr>
-          <a:lstStyle/>
-          <a:p>
-            <a:pPr algn="l"/>
-            <a:r>
-              <a:rPr lang="ru-RU" sz="3000" b="0" i="0" dirty="0">
-                <a:solidFill>
-                  <a:srgbClr val="3F3F3F"/>
-                </a:solidFill>
-                <a:effectLst/>
-              </a:rPr>
-              <a:t>Мы планируем интегрировать </a:t>
-            </a:r>
-            <a:r>
-              <a:rPr lang="ru-RU" sz="3000" b="0" i="0" dirty="0" err="1">
-                <a:solidFill>
-                  <a:srgbClr val="3F3F3F"/>
-                </a:solidFill>
-                <a:effectLst/>
-              </a:rPr>
-              <a:t>TastyAI</a:t>
-            </a:r>
-            <a:r>
-              <a:rPr lang="ru-RU" sz="3000" b="0" i="0" dirty="0">
-                <a:solidFill>
-                  <a:srgbClr val="3F3F3F"/>
-                </a:solidFill>
-                <a:effectLst/>
-              </a:rPr>
-              <a:t> с популярными образовательными платформами, чтобы сделать его доступным для еще большего числа пользователей.</a:t>
-            </a:r>
-          </a:p>
-          <a:p>
-            <a:pPr algn="l"/>
-            <a:r>
-              <a:rPr lang="ru-RU" sz="3000" dirty="0">
-                <a:solidFill>
-                  <a:srgbClr val="3F3F3F"/>
-                </a:solidFill>
-              </a:rPr>
-              <a:t>В том числе будут учителя и их ученики.</a:t>
-            </a:r>
-          </a:p>
-          <a:p>
-            <a:pPr algn="l"/>
-            <a:r>
-              <a:rPr lang="ru-RU" sz="3000" b="0" i="0" dirty="0">
-                <a:solidFill>
-                  <a:srgbClr val="3F3F3F"/>
-                </a:solidFill>
-                <a:effectLst/>
-              </a:rPr>
-              <a:t>Учителям к примеру это поможет изучить уровень знаний детей и их слабые стороны.</a:t>
-            </a:r>
-          </a:p>
-          <a:p>
-            <a:pPr algn="l"/>
-            <a:r>
-              <a:rPr lang="ru-RU" sz="3000" b="0" i="0" dirty="0">
-                <a:solidFill>
-                  <a:srgbClr val="3F3F3F"/>
-                </a:solidFill>
-                <a:effectLst/>
-              </a:rPr>
-              <a:t>Создани</a:t>
-            </a:r>
-            <a:r>
-              <a:rPr lang="ru-RU" sz="3000" dirty="0">
-                <a:solidFill>
-                  <a:srgbClr val="3F3F3F"/>
-                </a:solidFill>
-              </a:rPr>
-              <a:t>е сайтов с помощью ИИ поможет сделать много новых различных тестов на которые нет ответов</a:t>
-            </a:r>
-            <a:endParaRPr lang="ru-RU" sz="3000" b="0" i="0" dirty="0">
-              <a:solidFill>
-                <a:srgbClr val="3F3F3F"/>
-              </a:solidFill>
-              <a:effectLst/>
-            </a:endParaRPr>
-          </a:p>
-          <a:p>
-            <a:endParaRPr lang="ru-RU" dirty="0"/>
+              <a:t>Изображения</a:t>
+            </a:r>
           </a:p>
         </p:txBody>
       </p:sp>
       <p:pic>
         <p:nvPicPr>
-          <p:cNvPr id="1026" name="Picture 2" descr="Picture background">
-            <a:extLst>
-              <a:ext uri="{FF2B5EF4-FFF2-40B4-BE49-F238E27FC236}">
-                <a16:creationId xmlns:a16="http://schemas.microsoft.com/office/drawing/2014/main" id="{9CE56B79-4693-48DC-AD76-E497E1F4684E}"/>
+          <p:cNvPr id="5" name="Рисунок 4">
+            <a:extLst>
+              <a:ext uri="{FF2B5EF4-FFF2-40B4-BE49-F238E27FC236}">
+                <a16:creationId xmlns:a16="http://schemas.microsoft.com/office/drawing/2014/main" id="{783B9B83-C038-491C-B8B1-EFD27F3F25B1}"/>
               </a:ext>
             </a:extLst>
           </p:cNvPr>
           <p:cNvPicPr>
-            <a:picLocks noGrp="1" noChangeAspect="1" noChangeArrowheads="1"/>
+            <a:picLocks noChangeAspect="1"/>
           </p:cNvPicPr>
-          <p:nvPr>
-            <p:ph type="pic" sz="quarter" idx="13"/>
-          </p:nvPr>
+          <p:nvPr/>
         </p:nvPicPr>
-        <p:blipFill>
-          <a:blip r:embed="rId2">
-            <a:extLst>
-              <a:ext uri="{28A0092B-C50C-407E-A947-70E740481C1C}">
-                <a14:useLocalDpi xmlns:a14="http://schemas.microsoft.com/office/drawing/2010/main" val="0"/>
-              </a:ext>
-            </a:extLst>
-          </a:blip>
-          <a:srcRect l="22870" r="22870"/>
-          <a:stretch>
-            <a:fillRect/>
-          </a:stretch>
+        <p:blipFill rotWithShape="1">
+          <a:blip r:embed="rId2"/>
+          <a:srcRect l="17526" t="4303" r="19072"/>
+          <a:stretch/>
         </p:blipFill>
-        <p:spPr bwMode="auto">
+        <p:spPr>
+          <a:xfrm>
+            <a:off x="6096000" y="0"/>
+            <a:ext cx="6077065" cy="3463539"/>
+          </a:xfrm>
           <a:prstGeom prst="rect">
             <a:avLst/>
           </a:prstGeom>
-          <a:noFill/>
-          <a:extLst>
-            <a:ext uri="{909E8E84-426E-40DD-AFC4-6F175D3DCCD1}">
-              <a14:hiddenFill xmlns:a14="http://schemas.microsoft.com/office/drawing/2010/main">
-                <a:solidFill>
-                  <a:srgbClr val="FFFFFF"/>
-                </a:solidFill>
-              </a14:hiddenFill>
-            </a:ext>
-          </a:extLst>
+        </p:spPr>
+      </p:pic>
+      <p:pic>
+        <p:nvPicPr>
+          <p:cNvPr id="8" name="Рисунок 7">
+            <a:extLst>
+              <a:ext uri="{FF2B5EF4-FFF2-40B4-BE49-F238E27FC236}">
+                <a16:creationId xmlns:a16="http://schemas.microsoft.com/office/drawing/2014/main" id="{CFC8B641-984B-45A3-B475-65CBEB461EB0}"/>
+              </a:ext>
+            </a:extLst>
+          </p:cNvPr>
+          <p:cNvPicPr>
+            <a:picLocks noChangeAspect="1"/>
+          </p:cNvPicPr>
+          <p:nvPr/>
+        </p:nvPicPr>
+        <p:blipFill rotWithShape="1">
+          <a:blip r:embed="rId3"/>
+          <a:srcRect l="18814" t="4303" r="17783"/>
+          <a:stretch/>
+        </p:blipFill>
+        <p:spPr>
+          <a:xfrm>
+            <a:off x="5601098" y="3075373"/>
+            <a:ext cx="4609074" cy="3463539"/>
+          </a:xfrm>
+          <a:prstGeom prst="rect">
+            <a:avLst/>
+          </a:prstGeom>
+        </p:spPr>
+      </p:pic>
+      <p:pic>
+        <p:nvPicPr>
+          <p:cNvPr id="11" name="Рисунок 10">
+            <a:extLst>
+              <a:ext uri="{FF2B5EF4-FFF2-40B4-BE49-F238E27FC236}">
+                <a16:creationId xmlns:a16="http://schemas.microsoft.com/office/drawing/2014/main" id="{59763733-DDD1-4997-9E65-56ECD14E420C}"/>
+              </a:ext>
+            </a:extLst>
+          </p:cNvPr>
+          <p:cNvPicPr>
+            <a:picLocks noChangeAspect="1"/>
+          </p:cNvPicPr>
+          <p:nvPr/>
+        </p:nvPicPr>
+        <p:blipFill rotWithShape="1">
+          <a:blip r:embed="rId4"/>
+          <a:srcRect l="37470" t="16943" r="36990"/>
+          <a:stretch/>
+        </p:blipFill>
+        <p:spPr>
+          <a:xfrm>
+            <a:off x="9618820" y="3260212"/>
+            <a:ext cx="2554245" cy="2721487"/>
+          </a:xfrm>
+          <a:prstGeom prst="rect">
+            <a:avLst/>
+          </a:prstGeom>
+        </p:spPr>
+      </p:pic>
+      <p:sp>
+        <p:nvSpPr>
+          <p:cNvPr id="9" name="Нижний колонтитул 1">
+            <a:extLst>
+              <a:ext uri="{FF2B5EF4-FFF2-40B4-BE49-F238E27FC236}">
+                <a16:creationId xmlns:a16="http://schemas.microsoft.com/office/drawing/2014/main" id="{0341F986-0E76-44C8-8C6A-DFA469C75652}"/>
+              </a:ext>
+            </a:extLst>
+          </p:cNvPr>
+          <p:cNvSpPr txBox="1">
+            <a:spLocks/>
+          </p:cNvSpPr>
+          <p:nvPr/>
+        </p:nvSpPr>
+        <p:spPr>
+          <a:xfrm>
+            <a:off x="304802" y="6356350"/>
+            <a:ext cx="4114800" cy="365125"/>
+          </a:xfrm>
+          <a:prstGeom prst="rect">
+            <a:avLst/>
+          </a:prstGeom>
+        </p:spPr>
+        <p:txBody>
+          <a:bodyPr vert="horz" lIns="91440" tIns="45720" rIns="91440" bIns="45720" rtlCol="0" anchor="ctr"/>
+          <a:lstStyle>
+            <a:defPPr rtl="0">
+              <a:defRPr lang="ru-ru"/>
+            </a:defPPr>
+            <a:lvl1pPr marL="0" algn="l" defTabSz="914400" rtl="0" eaLnBrk="1" latinLnBrk="0" hangingPunct="1">
+              <a:defRPr sz="1200" kern="1200">
+                <a:solidFill>
+                  <a:schemeClr val="bg2"/>
+                </a:solidFill>
+                <a:latin typeface="+mn-lt"/>
+                <a:ea typeface="+mn-ea"/>
+                <a:cs typeface="+mn-cs"/>
+              </a:defRPr>
+            </a:lvl1pPr>
+            <a:lvl2pPr marL="457200" algn="l" defTabSz="914400" rtl="0" eaLnBrk="1" latinLnBrk="0" hangingPunct="1">
+              <a:defRPr sz="1800" kern="1200">
+                <a:solidFill>
+                  <a:schemeClr val="tx1"/>
+                </a:solidFill>
+                <a:latin typeface="+mn-lt"/>
+                <a:ea typeface="+mn-ea"/>
+                <a:cs typeface="+mn-cs"/>
+              </a:defRPr>
+            </a:lvl2pPr>
+            <a:lvl3pPr marL="914400" algn="l" defTabSz="914400" rtl="0" eaLnBrk="1" latinLnBrk="0" hangingPunct="1">
+              <a:defRPr sz="1800" kern="1200">
+                <a:solidFill>
+                  <a:schemeClr val="tx1"/>
+                </a:solidFill>
+                <a:latin typeface="+mn-lt"/>
+                <a:ea typeface="+mn-ea"/>
+                <a:cs typeface="+mn-cs"/>
+              </a:defRPr>
+            </a:lvl3pPr>
+            <a:lvl4pPr marL="1371600" algn="l" defTabSz="914400" rtl="0" eaLnBrk="1" latinLnBrk="0" hangingPunct="1">
+              <a:defRPr sz="1800" kern="1200">
+                <a:solidFill>
+                  <a:schemeClr val="tx1"/>
+                </a:solidFill>
+                <a:latin typeface="+mn-lt"/>
+                <a:ea typeface="+mn-ea"/>
+                <a:cs typeface="+mn-cs"/>
+              </a:defRPr>
+            </a:lvl4pPr>
+            <a:lvl5pPr marL="1828800" algn="l" defTabSz="914400" rtl="0" eaLnBrk="1" latinLnBrk="0" hangingPunct="1">
+              <a:defRPr sz="1800" kern="1200">
+                <a:solidFill>
+                  <a:schemeClr val="tx1"/>
+                </a:solidFill>
+                <a:latin typeface="+mn-lt"/>
+                <a:ea typeface="+mn-ea"/>
+                <a:cs typeface="+mn-cs"/>
+              </a:defRPr>
+            </a:lvl5pPr>
+            <a:lvl6pPr marL="2286000" algn="l" defTabSz="914400" rtl="0" eaLnBrk="1" latinLnBrk="0" hangingPunct="1">
+              <a:defRPr sz="1800" kern="1200">
+                <a:solidFill>
+                  <a:schemeClr val="tx1"/>
+                </a:solidFill>
+                <a:latin typeface="+mn-lt"/>
+                <a:ea typeface="+mn-ea"/>
+                <a:cs typeface="+mn-cs"/>
+              </a:defRPr>
+            </a:lvl6pPr>
+            <a:lvl7pPr marL="2743200" algn="l" defTabSz="914400" rtl="0" eaLnBrk="1" latinLnBrk="0" hangingPunct="1">
+              <a:defRPr sz="1800" kern="1200">
+                <a:solidFill>
+                  <a:schemeClr val="tx1"/>
+                </a:solidFill>
+                <a:latin typeface="+mn-lt"/>
+                <a:ea typeface="+mn-ea"/>
+                <a:cs typeface="+mn-cs"/>
+              </a:defRPr>
+            </a:lvl7pPr>
+            <a:lvl8pPr marL="3200400" algn="l" defTabSz="914400" rtl="0" eaLnBrk="1" latinLnBrk="0" hangingPunct="1">
+              <a:defRPr sz="1800" kern="1200">
+                <a:solidFill>
+                  <a:schemeClr val="tx1"/>
+                </a:solidFill>
+                <a:latin typeface="+mn-lt"/>
+                <a:ea typeface="+mn-ea"/>
+                <a:cs typeface="+mn-cs"/>
+              </a:defRPr>
+            </a:lvl8pPr>
+            <a:lvl9pPr marL="3657600" algn="l" defTabSz="914400" rtl="0" eaLnBrk="1" latinLnBrk="0" hangingPunct="1">
+              <a:defRPr sz="1800" kern="1200">
+                <a:solidFill>
+                  <a:schemeClr val="tx1"/>
+                </a:solidFill>
+                <a:latin typeface="+mn-lt"/>
+                <a:ea typeface="+mn-ea"/>
+                <a:cs typeface="+mn-cs"/>
+              </a:defRPr>
+            </a:lvl9pPr>
+          </a:lstStyle>
+          <a:p>
+            <a:r>
+              <a:rPr lang="en-US" sz="1800" dirty="0" err="1"/>
+              <a:t>tastyai-onlinetests.space</a:t>
+            </a:r>
+            <a:endParaRPr lang="ru-RU" sz="1800" dirty="0"/>
+          </a:p>
+        </p:txBody>
+      </p:sp>
+      <p:pic>
+        <p:nvPicPr>
+          <p:cNvPr id="6" name="Рисунок 5">
+            <a:extLst>
+              <a:ext uri="{FF2B5EF4-FFF2-40B4-BE49-F238E27FC236}">
+                <a16:creationId xmlns:a16="http://schemas.microsoft.com/office/drawing/2014/main" id="{97A2D71C-DAEB-4B15-947E-59A6608C41A9}"/>
+              </a:ext>
+            </a:extLst>
+          </p:cNvPr>
+          <p:cNvPicPr>
+            <a:picLocks noChangeAspect="1"/>
+          </p:cNvPicPr>
+          <p:nvPr/>
+        </p:nvPicPr>
+        <p:blipFill rotWithShape="1">
+          <a:blip r:embed="rId5"/>
+          <a:srcRect l="18897" r="19265" b="6063"/>
+          <a:stretch/>
+        </p:blipFill>
+        <p:spPr>
+          <a:xfrm>
+            <a:off x="97217" y="1343225"/>
+            <a:ext cx="6000262" cy="4507541"/>
+          </a:xfrm>
+          <a:prstGeom prst="rect">
+            <a:avLst/>
+          </a:prstGeom>
         </p:spPr>
       </p:pic>
     </p:spTree>
     <p:extLst>
       <p:ext uri="{BB962C8B-B14F-4D97-AF65-F5344CB8AC3E}">
-        <p14:creationId xmlns:p14="http://schemas.microsoft.com/office/powerpoint/2010/main" val="241966745"/>
+        <p14:creationId xmlns:p14="http://schemas.microsoft.com/office/powerpoint/2010/main" val="2257343127"/>
       </p:ext>
     </p:extLst>
   </p:cSld>
@@ -14791,551 +14618,6 @@
           <a:chExt cx="0" cy="0"/>
         </a:xfrm>
       </p:grpSpPr>
-      <p:sp>
-        <p:nvSpPr>
-          <p:cNvPr id="3" name="Номер слайда 2">
-            <a:extLst>
-              <a:ext uri="{FF2B5EF4-FFF2-40B4-BE49-F238E27FC236}">
-                <a16:creationId xmlns:a16="http://schemas.microsoft.com/office/drawing/2014/main" id="{613D1309-5330-4598-97FC-69345EEB1899}"/>
-              </a:ext>
-            </a:extLst>
-          </p:cNvPr>
-          <p:cNvSpPr>
-            <a:spLocks noGrp="1"/>
-          </p:cNvSpPr>
-          <p:nvPr>
-            <p:ph type="sldNum" sz="quarter" idx="18"/>
-          </p:nvPr>
-        </p:nvSpPr>
-        <p:spPr>
-          <a:xfrm>
-            <a:off x="10905026" y="6338017"/>
-            <a:ext cx="740227" cy="365125"/>
-          </a:xfrm>
-        </p:spPr>
-        <p:txBody>
-          <a:bodyPr/>
-          <a:lstStyle/>
-          <a:p>
-            <a:pPr rtl="0"/>
-            <a:fld id="{8699F50C-BE38-4BD0-BA84-9B090E1F2B9B}" type="slidenum">
-              <a:rPr lang="ru-RU" noProof="0" smtClean="0"/>
-              <a:t>6</a:t>
-            </a:fld>
-            <a:endParaRPr lang="ru-RU" noProof="0" dirty="0"/>
-          </a:p>
-        </p:txBody>
-      </p:sp>
-      <p:sp>
-        <p:nvSpPr>
-          <p:cNvPr id="4" name="Заголовок 3">
-            <a:extLst>
-              <a:ext uri="{FF2B5EF4-FFF2-40B4-BE49-F238E27FC236}">
-                <a16:creationId xmlns:a16="http://schemas.microsoft.com/office/drawing/2014/main" id="{B056112C-CEC6-4B47-83E7-7FB5130C01B1}"/>
-              </a:ext>
-            </a:extLst>
-          </p:cNvPr>
-          <p:cNvSpPr>
-            <a:spLocks noGrp="1"/>
-          </p:cNvSpPr>
-          <p:nvPr>
-            <p:ph type="title"/>
-          </p:nvPr>
-        </p:nvSpPr>
-        <p:spPr>
-          <a:xfrm>
-            <a:off x="786749" y="-65249"/>
-            <a:ext cx="8333222" cy="777090"/>
-          </a:xfrm>
-        </p:spPr>
-        <p:txBody>
-          <a:bodyPr/>
-          <a:lstStyle/>
-          <a:p>
-            <a:r>
-              <a:rPr lang="ru-RU" dirty="0" err="1"/>
-              <a:t>Пикчи</a:t>
-            </a:r>
-            <a:endParaRPr lang="ru-RU" dirty="0"/>
-          </a:p>
-        </p:txBody>
-      </p:sp>
-      <p:sp>
-        <p:nvSpPr>
-          <p:cNvPr id="25" name="Нижний колонтитул 1">
-            <a:extLst>
-              <a:ext uri="{FF2B5EF4-FFF2-40B4-BE49-F238E27FC236}">
-                <a16:creationId xmlns:a16="http://schemas.microsoft.com/office/drawing/2014/main" id="{EAEBD4E4-993B-4A8F-B8A4-276C90C3686A}"/>
-              </a:ext>
-            </a:extLst>
-          </p:cNvPr>
-          <p:cNvSpPr>
-            <a:spLocks noGrp="1"/>
-          </p:cNvSpPr>
-          <p:nvPr>
-            <p:ph type="ftr" sz="quarter" idx="17"/>
-          </p:nvPr>
-        </p:nvSpPr>
-        <p:spPr>
-          <a:xfrm>
-            <a:off x="3155575" y="154858"/>
-            <a:ext cx="4114800" cy="365125"/>
-          </a:xfrm>
-        </p:spPr>
-        <p:txBody>
-          <a:bodyPr/>
-          <a:lstStyle/>
-          <a:p>
-            <a:pPr rtl="0"/>
-            <a:r>
-              <a:rPr lang="en-US" sz="1800" dirty="0" err="1"/>
-              <a:t>tastyai-onlinetests.space</a:t>
-            </a:r>
-            <a:endParaRPr lang="ru-RU" sz="1800" noProof="0" dirty="0"/>
-          </a:p>
-        </p:txBody>
-      </p:sp>
-      <p:pic>
-        <p:nvPicPr>
-          <p:cNvPr id="5" name="Рисунок 4">
-            <a:extLst>
-              <a:ext uri="{FF2B5EF4-FFF2-40B4-BE49-F238E27FC236}">
-                <a16:creationId xmlns:a16="http://schemas.microsoft.com/office/drawing/2014/main" id="{783B9B83-C038-491C-B8B1-EFD27F3F25B1}"/>
-              </a:ext>
-            </a:extLst>
-          </p:cNvPr>
-          <p:cNvPicPr>
-            <a:picLocks noChangeAspect="1"/>
-          </p:cNvPicPr>
-          <p:nvPr/>
-        </p:nvPicPr>
-        <p:blipFill rotWithShape="1">
-          <a:blip r:embed="rId2"/>
-          <a:srcRect l="17526" t="4303" r="19072"/>
-          <a:stretch/>
-        </p:blipFill>
-        <p:spPr>
-          <a:xfrm>
-            <a:off x="5699027" y="154858"/>
-            <a:ext cx="6077065" cy="3463539"/>
-          </a:xfrm>
-          <a:prstGeom prst="rect">
-            <a:avLst/>
-          </a:prstGeom>
-        </p:spPr>
-      </p:pic>
-      <p:pic>
-        <p:nvPicPr>
-          <p:cNvPr id="8" name="Рисунок 7">
-            <a:extLst>
-              <a:ext uri="{FF2B5EF4-FFF2-40B4-BE49-F238E27FC236}">
-                <a16:creationId xmlns:a16="http://schemas.microsoft.com/office/drawing/2014/main" id="{CFC8B641-984B-45A3-B475-65CBEB461EB0}"/>
-              </a:ext>
-            </a:extLst>
-          </p:cNvPr>
-          <p:cNvPicPr>
-            <a:picLocks noChangeAspect="1"/>
-          </p:cNvPicPr>
-          <p:nvPr/>
-        </p:nvPicPr>
-        <p:blipFill rotWithShape="1">
-          <a:blip r:embed="rId3"/>
-          <a:srcRect l="18814" t="4303" r="17783"/>
-          <a:stretch/>
-        </p:blipFill>
-        <p:spPr>
-          <a:xfrm>
-            <a:off x="1089954" y="689898"/>
-            <a:ext cx="4609074" cy="3463539"/>
-          </a:xfrm>
-          <a:prstGeom prst="rect">
-            <a:avLst/>
-          </a:prstGeom>
-        </p:spPr>
-      </p:pic>
-      <p:pic>
-        <p:nvPicPr>
-          <p:cNvPr id="11" name="Рисунок 10">
-            <a:extLst>
-              <a:ext uri="{FF2B5EF4-FFF2-40B4-BE49-F238E27FC236}">
-                <a16:creationId xmlns:a16="http://schemas.microsoft.com/office/drawing/2014/main" id="{59763733-DDD1-4997-9E65-56ECD14E420C}"/>
-              </a:ext>
-            </a:extLst>
-          </p:cNvPr>
-          <p:cNvPicPr>
-            <a:picLocks noChangeAspect="1"/>
-          </p:cNvPicPr>
-          <p:nvPr/>
-        </p:nvPicPr>
-        <p:blipFill rotWithShape="1">
-          <a:blip r:embed="rId4"/>
-          <a:srcRect l="18456" t="6121" r="18162"/>
-          <a:stretch/>
-        </p:blipFill>
-        <p:spPr>
-          <a:xfrm>
-            <a:off x="5824599" y="3920653"/>
-            <a:ext cx="5450541" cy="2645079"/>
-          </a:xfrm>
-          <a:prstGeom prst="rect">
-            <a:avLst/>
-          </a:prstGeom>
-        </p:spPr>
-      </p:pic>
-      <p:pic>
-        <p:nvPicPr>
-          <p:cNvPr id="14" name="Рисунок 13">
-            <a:extLst>
-              <a:ext uri="{FF2B5EF4-FFF2-40B4-BE49-F238E27FC236}">
-                <a16:creationId xmlns:a16="http://schemas.microsoft.com/office/drawing/2014/main" id="{B910F12B-D98D-4CB9-9B6E-4A005310DA34}"/>
-              </a:ext>
-            </a:extLst>
-          </p:cNvPr>
-          <p:cNvPicPr>
-            <a:picLocks noChangeAspect="1"/>
-          </p:cNvPicPr>
-          <p:nvPr/>
-        </p:nvPicPr>
-        <p:blipFill rotWithShape="1">
-          <a:blip r:embed="rId5"/>
-          <a:srcRect l="17353" t="5359" r="18530"/>
-          <a:stretch/>
-        </p:blipFill>
-        <p:spPr>
-          <a:xfrm>
-            <a:off x="-171532" y="4153437"/>
-            <a:ext cx="5996131" cy="2844655"/>
-          </a:xfrm>
-          <a:prstGeom prst="rect">
-            <a:avLst/>
-          </a:prstGeom>
-        </p:spPr>
-      </p:pic>
-    </p:spTree>
-    <p:extLst>
-      <p:ext uri="{BB962C8B-B14F-4D97-AF65-F5344CB8AC3E}">
-        <p14:creationId xmlns:p14="http://schemas.microsoft.com/office/powerpoint/2010/main" val="2257343127"/>
-      </p:ext>
-    </p:extLst>
-  </p:cSld>
-  <p:clrMapOvr>
-    <a:masterClrMapping/>
-  </p:clrMapOvr>
-</p:sld>
-</file>
-
-<file path=ppt/slides/slide7.xml><?xml version="1.0" encoding="utf-8"?>
-<p:sld xmlns:a="http://schemas.openxmlformats.org/drawingml/2006/main" xmlns:r="http://schemas.openxmlformats.org/officeDocument/2006/relationships" xmlns:p="http://schemas.openxmlformats.org/presentationml/2006/main">
-  <p:cSld>
-    <p:spTree>
-      <p:nvGrpSpPr>
-        <p:cNvPr id="1" name=""/>
-        <p:cNvGrpSpPr/>
-        <p:nvPr/>
-      </p:nvGrpSpPr>
-      <p:grpSpPr>
-        <a:xfrm>
-          <a:off x="0" y="0"/>
-          <a:ext cx="0" cy="0"/>
-          <a:chOff x="0" y="0"/>
-          <a:chExt cx="0" cy="0"/>
-        </a:xfrm>
-      </p:grpSpPr>
-      <p:sp>
-        <p:nvSpPr>
-          <p:cNvPr id="2" name="Нижний колонтитул 1">
-            <a:extLst>
-              <a:ext uri="{FF2B5EF4-FFF2-40B4-BE49-F238E27FC236}">
-                <a16:creationId xmlns:a16="http://schemas.microsoft.com/office/drawing/2014/main" id="{7C1268C0-519A-40C4-97BD-3CE108ED1611}"/>
-              </a:ext>
-            </a:extLst>
-          </p:cNvPr>
-          <p:cNvSpPr>
-            <a:spLocks noGrp="1"/>
-          </p:cNvSpPr>
-          <p:nvPr>
-            <p:ph type="ftr" sz="quarter" idx="17"/>
-          </p:nvPr>
-        </p:nvSpPr>
-        <p:spPr/>
-        <p:txBody>
-          <a:bodyPr/>
-          <a:lstStyle/>
-          <a:p>
-            <a:pPr rtl="0"/>
-            <a:r>
-              <a:rPr lang="en-US" sz="1800" dirty="0" err="1"/>
-              <a:t>tastyai-onlinetests.space</a:t>
-            </a:r>
-            <a:endParaRPr lang="ru-RU" sz="1800" noProof="0" dirty="0"/>
-          </a:p>
-        </p:txBody>
-      </p:sp>
-      <p:sp>
-        <p:nvSpPr>
-          <p:cNvPr id="3" name="Номер слайда 2">
-            <a:extLst>
-              <a:ext uri="{FF2B5EF4-FFF2-40B4-BE49-F238E27FC236}">
-                <a16:creationId xmlns:a16="http://schemas.microsoft.com/office/drawing/2014/main" id="{79319688-64FF-49B8-BF18-25B049F6C67C}"/>
-              </a:ext>
-            </a:extLst>
-          </p:cNvPr>
-          <p:cNvSpPr>
-            <a:spLocks noGrp="1"/>
-          </p:cNvSpPr>
-          <p:nvPr>
-            <p:ph type="sldNum" sz="quarter" idx="18"/>
-          </p:nvPr>
-        </p:nvSpPr>
-        <p:spPr>
-          <a:xfrm>
-            <a:off x="11146971" y="6356350"/>
-            <a:ext cx="725485" cy="365125"/>
-          </a:xfrm>
-        </p:spPr>
-        <p:txBody>
-          <a:bodyPr/>
-          <a:lstStyle/>
-          <a:p>
-            <a:pPr rtl="0"/>
-            <a:fld id="{8699F50C-BE38-4BD0-BA84-9B090E1F2B9B}" type="slidenum">
-              <a:rPr lang="ru-RU" noProof="0" smtClean="0"/>
-              <a:t>7</a:t>
-            </a:fld>
-            <a:endParaRPr lang="ru-RU" noProof="0" dirty="0"/>
-          </a:p>
-        </p:txBody>
-      </p:sp>
-      <p:sp>
-        <p:nvSpPr>
-          <p:cNvPr id="4" name="Заголовок 3">
-            <a:extLst>
-              <a:ext uri="{FF2B5EF4-FFF2-40B4-BE49-F238E27FC236}">
-                <a16:creationId xmlns:a16="http://schemas.microsoft.com/office/drawing/2014/main" id="{699B28CC-62D3-4D43-829C-2157F15DD932}"/>
-              </a:ext>
-            </a:extLst>
-          </p:cNvPr>
-          <p:cNvSpPr>
-            <a:spLocks noGrp="1"/>
-          </p:cNvSpPr>
-          <p:nvPr>
-            <p:ph type="title"/>
-          </p:nvPr>
-        </p:nvSpPr>
-        <p:spPr/>
-        <p:txBody>
-          <a:bodyPr/>
-          <a:lstStyle/>
-          <a:p>
-            <a:r>
-              <a:rPr lang="ru-RU" dirty="0"/>
-              <a:t>Состояние проекта</a:t>
-            </a:r>
-          </a:p>
-        </p:txBody>
-      </p:sp>
-      <p:sp>
-        <p:nvSpPr>
-          <p:cNvPr id="5" name="Текст 4">
-            <a:extLst>
-              <a:ext uri="{FF2B5EF4-FFF2-40B4-BE49-F238E27FC236}">
-                <a16:creationId xmlns:a16="http://schemas.microsoft.com/office/drawing/2014/main" id="{8C6C43A5-DCEA-4BC3-8457-ABA621680DD6}"/>
-              </a:ext>
-            </a:extLst>
-          </p:cNvPr>
-          <p:cNvSpPr>
-            <a:spLocks noGrp="1"/>
-          </p:cNvSpPr>
-          <p:nvPr>
-            <p:ph type="body" idx="1"/>
-          </p:nvPr>
-        </p:nvSpPr>
-        <p:spPr>
-          <a:xfrm>
-            <a:off x="704251" y="1501042"/>
-            <a:ext cx="5382501" cy="461122"/>
-          </a:xfrm>
-        </p:spPr>
-        <p:txBody>
-          <a:bodyPr/>
-          <a:lstStyle/>
-          <a:p>
-            <a:r>
-              <a:rPr lang="ru-RU" dirty="0"/>
-              <a:t>Что уже сделано</a:t>
-            </a:r>
-          </a:p>
-        </p:txBody>
-      </p:sp>
-      <p:sp>
-        <p:nvSpPr>
-          <p:cNvPr id="7" name="Объект 6">
-            <a:extLst>
-              <a:ext uri="{FF2B5EF4-FFF2-40B4-BE49-F238E27FC236}">
-                <a16:creationId xmlns:a16="http://schemas.microsoft.com/office/drawing/2014/main" id="{8EECC8B3-3F38-4FC5-8790-865781C73945}"/>
-              </a:ext>
-            </a:extLst>
-          </p:cNvPr>
-          <p:cNvSpPr>
-            <a:spLocks noGrp="1"/>
-          </p:cNvSpPr>
-          <p:nvPr>
-            <p:ph sz="quarter" idx="4"/>
-          </p:nvPr>
-        </p:nvSpPr>
-        <p:spPr>
-          <a:xfrm>
-            <a:off x="5800165" y="1962162"/>
-            <a:ext cx="5275309" cy="2849198"/>
-          </a:xfrm>
-        </p:spPr>
-        <p:txBody>
-          <a:bodyPr/>
-          <a:lstStyle/>
-          <a:p>
-            <a:r>
-              <a:rPr lang="ru-RU" dirty="0"/>
-              <a:t>✨Редактор тестов✨</a:t>
-            </a:r>
-          </a:p>
-          <a:p>
-            <a:r>
-              <a:rPr lang="ru-RU" dirty="0"/>
-              <a:t>Создание тестов с помощью 🤖ИИ (функция, доступна в редакторе)</a:t>
-            </a:r>
-          </a:p>
-          <a:p>
-            <a:r>
-              <a:rPr lang="ru-RU" dirty="0"/>
-              <a:t>✨Оптимизация сайта под 📲смартфоны!✨</a:t>
-            </a:r>
-          </a:p>
-        </p:txBody>
-      </p:sp>
-      <p:sp>
-        <p:nvSpPr>
-          <p:cNvPr id="8" name="Объект 7">
-            <a:extLst>
-              <a:ext uri="{FF2B5EF4-FFF2-40B4-BE49-F238E27FC236}">
-                <a16:creationId xmlns:a16="http://schemas.microsoft.com/office/drawing/2014/main" id="{9E7624E5-4732-466B-B364-8A7EFE18D196}"/>
-              </a:ext>
-            </a:extLst>
-          </p:cNvPr>
-          <p:cNvSpPr>
-            <a:spLocks noGrp="1"/>
-          </p:cNvSpPr>
-          <p:nvPr>
-            <p:ph sz="half" idx="2"/>
-          </p:nvPr>
-        </p:nvSpPr>
-        <p:spPr>
-          <a:xfrm>
-            <a:off x="704252" y="1962163"/>
-            <a:ext cx="5379492" cy="3658707"/>
-          </a:xfrm>
-        </p:spPr>
-        <p:txBody>
-          <a:bodyPr/>
-          <a:lstStyle/>
-          <a:p>
-            <a:r>
-              <a:rPr lang="ru-RU" dirty="0"/>
-              <a:t>✨Стиль сайта✨</a:t>
-            </a:r>
-          </a:p>
-          <a:p>
-            <a:r>
-              <a:rPr lang="ru-RU" dirty="0"/>
-              <a:t>✨Главная страница✨</a:t>
-            </a:r>
-          </a:p>
-          <a:p>
-            <a:r>
-              <a:rPr lang="ru-RU" dirty="0"/>
-              <a:t>Страница готовых тестов с 🔎поиском</a:t>
-            </a:r>
-          </a:p>
-          <a:p>
-            <a:r>
-              <a:rPr lang="ru-RU" dirty="0"/>
-              <a:t>Страница авторизации, а так же хранение данных о пользователях</a:t>
-            </a:r>
-            <a:endParaRPr lang="en-US" dirty="0"/>
-          </a:p>
-          <a:p>
-            <a:r>
-              <a:rPr lang="ru-RU" dirty="0"/>
-              <a:t>Возможность прохождения🙌 тестов</a:t>
-            </a:r>
-          </a:p>
-          <a:p>
-            <a:r>
-              <a:rPr lang="ru-RU" dirty="0"/>
-              <a:t>Индивидуальные результаты💡 на тесты</a:t>
-            </a:r>
-          </a:p>
-        </p:txBody>
-      </p:sp>
-      <p:pic>
-        <p:nvPicPr>
-          <p:cNvPr id="9" name="Рисунок 8">
-            <a:extLst>
-              <a:ext uri="{FF2B5EF4-FFF2-40B4-BE49-F238E27FC236}">
-                <a16:creationId xmlns:a16="http://schemas.microsoft.com/office/drawing/2014/main" id="{447046DE-31EE-4BD5-97D1-C9C00E363062}"/>
-              </a:ext>
-            </a:extLst>
-          </p:cNvPr>
-          <p:cNvPicPr>
-            <a:picLocks noChangeAspect="1"/>
-          </p:cNvPicPr>
-          <p:nvPr/>
-        </p:nvPicPr>
-        <p:blipFill>
-          <a:blip r:embed="rId2"/>
-          <a:stretch>
-            <a:fillRect/>
-          </a:stretch>
-        </p:blipFill>
-        <p:spPr>
-          <a:xfrm>
-            <a:off x="6108258" y="5416529"/>
-            <a:ext cx="3529818" cy="982987"/>
-          </a:xfrm>
-          <a:prstGeom prst="rect">
-            <a:avLst/>
-          </a:prstGeom>
-        </p:spPr>
-      </p:pic>
-    </p:spTree>
-    <p:extLst>
-      <p:ext uri="{BB962C8B-B14F-4D97-AF65-F5344CB8AC3E}">
-        <p14:creationId xmlns:p14="http://schemas.microsoft.com/office/powerpoint/2010/main" val="3125771903"/>
-      </p:ext>
-    </p:extLst>
-  </p:cSld>
-  <p:clrMapOvr>
-    <a:masterClrMapping/>
-  </p:clrMapOvr>
-</p:sld>
-</file>
-
-<file path=ppt/slides/slide8.xml><?xml version="1.0" encoding="utf-8"?>
-<p:sld xmlns:a="http://schemas.openxmlformats.org/drawingml/2006/main" xmlns:r="http://schemas.openxmlformats.org/officeDocument/2006/relationships" xmlns:p="http://schemas.openxmlformats.org/presentationml/2006/main">
-  <p:cSld>
-    <p:spTree>
-      <p:nvGrpSpPr>
-        <p:cNvPr id="1" name=""/>
-        <p:cNvGrpSpPr/>
-        <p:nvPr/>
-      </p:nvGrpSpPr>
-      <p:grpSpPr>
-        <a:xfrm>
-          <a:off x="0" y="0"/>
-          <a:ext cx="0" cy="0"/>
-          <a:chOff x="0" y="0"/>
-          <a:chExt cx="0" cy="0"/>
-        </a:xfrm>
-      </p:grpSpPr>
       <p:pic>
         <p:nvPicPr>
           <p:cNvPr id="17" name="Рисунок 16" title="Изображение здания">
@@ -15471,7 +14753,15 @@
             <a:pPr rtl="0"/>
             <a:r>
               <a:rPr lang="ru-RU" dirty="0"/>
-              <a:t>Воплощение кейса: «Веб-сервис для создания и проведения опросов с визуализацией результатов»</a:t>
+              <a:t>«Проект </a:t>
+            </a:r>
+            <a:r>
+              <a:rPr lang="ru-RU" dirty="0" err="1"/>
+              <a:t>WebServer</a:t>
+            </a:r>
+            <a:r>
+              <a:rPr lang="ru-RU" dirty="0"/>
+              <a:t> + API» для курса Промышленное программирование в Яндекс Лицее</a:t>
             </a:r>
           </a:p>
         </p:txBody>
@@ -15521,7 +14811,7 @@
         <p:spPr>
           <a:xfrm>
             <a:off x="6375214" y="5074755"/>
-            <a:ext cx="4697506" cy="369332"/>
+            <a:ext cx="4697506" cy="646331"/>
           </a:xfrm>
           <a:prstGeom prst="rect">
             <a:avLst/>
@@ -15536,7 +14826,17 @@
           <a:p>
             <a:r>
               <a:rPr lang="ru-RU" dirty="0"/>
-              <a:t>г. Нижневартовск, МБОУ «Лицей №2» 8 класс</a:t>
+              <a:t>Минибаев Артём, </a:t>
+            </a:r>
+            <a:r>
+              <a:rPr lang="ru-RU"/>
+              <a:t>Савицкий Тимофей</a:t>
+            </a:r>
+          </a:p>
+          <a:p>
+            <a:r>
+              <a:rPr lang="ru-RU" dirty="0"/>
+              <a:t>г. Нижневартовск, МБОУ «Лицей №2» 9 класс</a:t>
             </a:r>
           </a:p>
         </p:txBody>
@@ -15571,46 +14871,6 @@
           </a:prstGeom>
         </p:spPr>
       </p:pic>
-      <p:sp>
-        <p:nvSpPr>
-          <p:cNvPr id="9" name="TextBox 8">
-            <a:extLst>
-              <a:ext uri="{FF2B5EF4-FFF2-40B4-BE49-F238E27FC236}">
-                <a16:creationId xmlns:a16="http://schemas.microsoft.com/office/drawing/2014/main" id="{58A97172-8644-4B8B-AF10-1A80068E576D}"/>
-              </a:ext>
-            </a:extLst>
-          </p:cNvPr>
-          <p:cNvSpPr txBox="1"/>
-          <p:nvPr/>
-        </p:nvSpPr>
-        <p:spPr>
-          <a:xfrm>
-            <a:off x="6375214" y="5462748"/>
-            <a:ext cx="4697506" cy="369332"/>
-          </a:xfrm>
-          <a:prstGeom prst="rect">
-            <a:avLst/>
-          </a:prstGeom>
-          <a:noFill/>
-        </p:spPr>
-        <p:txBody>
-          <a:bodyPr wrap="square" rtlCol="0">
-            <a:spAutoFit/>
-          </a:bodyPr>
-          <a:lstStyle/>
-          <a:p>
-            <a:r>
-              <a:rPr lang="ru-RU" dirty="0"/>
-              <a:t>📱+79227819422	✉️</a:t>
-            </a:r>
-            <a:r>
-              <a:rPr lang="en-US" dirty="0"/>
-              <a:t>hornid2010@mail.ru</a:t>
-            </a:r>
-            <a:endParaRPr lang="ru-RU" dirty="0"/>
-          </a:p>
-        </p:txBody>
-      </p:sp>
       <p:sp>
         <p:nvSpPr>
           <p:cNvPr id="10" name="Нижний колонтитул 1">
@@ -16605,12 +15865,12 @@
 </file>
 
 <file path=customXml/item1.xml><?xml version="1.0" encoding="utf-8"?>
-<p:properties xmlns:p="http://schemas.microsoft.com/office/2006/metadata/properties" xmlns:xsi="http://www.w3.org/2001/XMLSchema-instance" xmlns:pc="http://schemas.microsoft.com/office/infopath/2007/PartnerControls">
-  <documentManagement>
-    <MediaServiceKeyPoints xmlns="71af3243-3dd4-4a8d-8c0d-dd76da1f02a5" xsi:nil="true"/>
-    <Status xmlns="71af3243-3dd4-4a8d-8c0d-dd76da1f02a5">Not started</Status>
-  </documentManagement>
-</p:properties>
+<?mso-contentType ?>
+<FormTemplates xmlns="http://schemas.microsoft.com/sharepoint/v3/contenttype/forms">
+  <Display>DocumentLibraryForm</Display>
+  <Edit>DocumentLibraryForm</Edit>
+  <New>DocumentLibraryForm</New>
+</FormTemplates>
 </file>
 
 <file path=customXml/item2.xml><?xml version="1.0" encoding="utf-8"?>
@@ -16835,20 +16095,18 @@
 </file>
 
 <file path=customXml/item3.xml><?xml version="1.0" encoding="utf-8"?>
-<?mso-contentType ?>
-<FormTemplates xmlns="http://schemas.microsoft.com/sharepoint/v3/contenttype/forms">
-  <Display>DocumentLibraryForm</Display>
-  <Edit>DocumentLibraryForm</Edit>
-  <New>DocumentLibraryForm</New>
-</FormTemplates>
+<p:properties xmlns:p="http://schemas.microsoft.com/office/2006/metadata/properties" xmlns:xsi="http://www.w3.org/2001/XMLSchema-instance" xmlns:pc="http://schemas.microsoft.com/office/infopath/2007/PartnerControls">
+  <documentManagement>
+    <MediaServiceKeyPoints xmlns="71af3243-3dd4-4a8d-8c0d-dd76da1f02a5" xsi:nil="true"/>
+    <Status xmlns="71af3243-3dd4-4a8d-8c0d-dd76da1f02a5">Not started</Status>
+  </documentManagement>
+</p:properties>
 </file>
 
 <file path=customXml/itemProps1.xml><?xml version="1.0" encoding="utf-8"?>
-<ds:datastoreItem xmlns:ds="http://schemas.openxmlformats.org/officeDocument/2006/customXml" ds:itemID="{289220B3-790D-4FDF-A046-BB08A9FCEE9A}">
+<ds:datastoreItem xmlns:ds="http://schemas.openxmlformats.org/officeDocument/2006/customXml" ds:itemID="{4B57EF8E-3088-4B8D-AE89-9AA6B62E9636}">
   <ds:schemaRefs>
-    <ds:schemaRef ds:uri="http://schemas.microsoft.com/office/2006/metadata/properties"/>
-    <ds:schemaRef ds:uri="http://schemas.microsoft.com/office/infopath/2007/PartnerControls"/>
-    <ds:schemaRef ds:uri="71af3243-3dd4-4a8d-8c0d-dd76da1f02a5"/>
+    <ds:schemaRef ds:uri="http://schemas.microsoft.com/sharepoint/v3/contenttype/forms"/>
   </ds:schemaRefs>
 </ds:datastoreItem>
 </file>
@@ -16873,9 +16131,11 @@
 </file>
 
 <file path=customXml/itemProps3.xml><?xml version="1.0" encoding="utf-8"?>
-<ds:datastoreItem xmlns:ds="http://schemas.openxmlformats.org/officeDocument/2006/customXml" ds:itemID="{4B57EF8E-3088-4B8D-AE89-9AA6B62E9636}">
+<ds:datastoreItem xmlns:ds="http://schemas.openxmlformats.org/officeDocument/2006/customXml" ds:itemID="{289220B3-790D-4FDF-A046-BB08A9FCEE9A}">
   <ds:schemaRefs>
-    <ds:schemaRef ds:uri="http://schemas.microsoft.com/sharepoint/v3/contenttype/forms"/>
+    <ds:schemaRef ds:uri="http://schemas.microsoft.com/office/2006/metadata/properties"/>
+    <ds:schemaRef ds:uri="http://schemas.microsoft.com/office/infopath/2007/PartnerControls"/>
+    <ds:schemaRef ds:uri="71af3243-3dd4-4a8d-8c0d-dd76da1f02a5"/>
   </ds:schemaRefs>
 </ds:datastoreItem>
 </file>
</xml_diff>